<commit_message>
(4.21) ppt 파일 복구
</commit_message>
<xml_diff>
--- a/(4.16) 캐릭터 시트.pptx
+++ b/(4.16) 캐릭터 시트.pptx
@@ -8,10 +8,17 @@
     <p:sldId id="257" r:id="rId2"/>
     <p:sldId id="258" r:id="rId3"/>
     <p:sldId id="259" r:id="rId4"/>
-    <p:sldId id="260" r:id="rId5"/>
-    <p:sldId id="261" r:id="rId6"/>
-    <p:sldId id="262" r:id="rId7"/>
-    <p:sldId id="263" r:id="rId8"/>
+    <p:sldId id="262" r:id="rId5"/>
+    <p:sldId id="263" r:id="rId6"/>
+    <p:sldId id="264" r:id="rId7"/>
+    <p:sldId id="265" r:id="rId8"/>
+    <p:sldId id="268" r:id="rId9"/>
+    <p:sldId id="266" r:id="rId10"/>
+    <p:sldId id="267" r:id="rId11"/>
+    <p:sldId id="269" r:id="rId12"/>
+    <p:sldId id="261" r:id="rId13"/>
+    <p:sldId id="260" r:id="rId14"/>
+    <p:sldId id="270" r:id="rId15"/>
   </p:sldIdLst>
   <p:sldSz cx="12192000" cy="6858000"/>
   <p:notesSz cx="6858000" cy="9144000"/>
@@ -110,7 +117,305 @@
       </a:defRPr>
     </a:lvl9pPr>
   </p:defaultTextStyle>
+  <p:extLst>
+    <p:ext uri="{EFAFB233-063F-42B5-8137-9DF3F51BA10A}">
+      <p15:sldGuideLst xmlns:p15="http://schemas.microsoft.com/office/powerpoint/2012/main"/>
+    </p:ext>
+  </p:extLst>
 </p:presentation>
+</file>
+
+<file path=ppt/revisionInfo.xml><?xml version="1.0" encoding="utf-8"?>
+<p1510:revInfo xmlns:a="http://schemas.openxmlformats.org/drawingml/2006/main" xmlns:r="http://schemas.openxmlformats.org/officeDocument/2006/relationships" xmlns:p1510="http://schemas.microsoft.com/office/powerpoint/2015/10/main">
+  <p1510:revLst>
+    <p1510:client id="{765A7947-D1B3-48A6-B476-FCBE36B4506F}" v="24" dt="2026-04-17T04:18:13.866"/>
+  </p1510:revLst>
+</p1510:revInfo>
+</file>
+
+<file path=ppt/changesInfos/changesInfo1.xml><?xml version="1.0" encoding="utf-8"?>
+<pc:chgInfo xmlns:a="http://schemas.openxmlformats.org/drawingml/2006/main" xmlns:r="http://schemas.openxmlformats.org/officeDocument/2006/relationships" xmlns:ac="http://schemas.microsoft.com/office/drawing/2013/main/command" xmlns:pc="http://schemas.microsoft.com/office/powerpoint/2013/main/command">
+  <pc:docChgLst>
+    <pc:chgData name="musukie52@gmail.com" userId="017bd91f96aa8751" providerId="LiveId" clId="{5B2C3894-F97E-4CAB-8812-5BB4D83AAC6A}"/>
+    <pc:docChg chg="undo custSel addSld delSld modSld">
+      <pc:chgData name="musukie52@gmail.com" userId="017bd91f96aa8751" providerId="LiveId" clId="{5B2C3894-F97E-4CAB-8812-5BB4D83AAC6A}" dt="2026-04-17T04:19:11.713" v="1452" actId="1076"/>
+      <pc:docMkLst>
+        <pc:docMk/>
+      </pc:docMkLst>
+      <pc:sldChg chg="addSp delSp modSp mod">
+        <pc:chgData name="musukie52@gmail.com" userId="017bd91f96aa8751" providerId="LiveId" clId="{5B2C3894-F97E-4CAB-8812-5BB4D83AAC6A}" dt="2026-04-17T04:11:28.468" v="522" actId="21"/>
+        <pc:sldMkLst>
+          <pc:docMk/>
+          <pc:sldMk cId="1102067116" sldId="263"/>
+        </pc:sldMkLst>
+        <pc:graphicFrameChg chg="mod modGraphic">
+          <ac:chgData name="musukie52@gmail.com" userId="017bd91f96aa8751" providerId="LiveId" clId="{5B2C3894-F97E-4CAB-8812-5BB4D83AAC6A}" dt="2026-04-17T02:50:31.551" v="514" actId="20577"/>
+          <ac:graphicFrameMkLst>
+            <pc:docMk/>
+            <pc:sldMk cId="1102067116" sldId="263"/>
+            <ac:graphicFrameMk id="4" creationId="{00000000-0000-0000-0000-000000000000}"/>
+          </ac:graphicFrameMkLst>
+        </pc:graphicFrameChg>
+        <pc:picChg chg="add del mod">
+          <ac:chgData name="musukie52@gmail.com" userId="017bd91f96aa8751" providerId="LiveId" clId="{5B2C3894-F97E-4CAB-8812-5BB4D83AAC6A}" dt="2026-04-17T04:11:28.468" v="522" actId="21"/>
+          <ac:picMkLst>
+            <pc:docMk/>
+            <pc:sldMk cId="1102067116" sldId="263"/>
+            <ac:picMk id="3" creationId="{264C48D4-C573-38B0-FCB7-926EACD0AA91}"/>
+          </ac:picMkLst>
+        </pc:picChg>
+        <pc:picChg chg="mod">
+          <ac:chgData name="musukie52@gmail.com" userId="017bd91f96aa8751" providerId="LiveId" clId="{5B2C3894-F97E-4CAB-8812-5BB4D83AAC6A}" dt="2026-04-17T02:47:39.709" v="26" actId="1076"/>
+          <ac:picMkLst>
+            <pc:docMk/>
+            <pc:sldMk cId="1102067116" sldId="263"/>
+            <ac:picMk id="5" creationId="{00000000-0000-0000-0000-000000000000}"/>
+          </ac:picMkLst>
+        </pc:picChg>
+        <pc:picChg chg="mod">
+          <ac:chgData name="musukie52@gmail.com" userId="017bd91f96aa8751" providerId="LiveId" clId="{5B2C3894-F97E-4CAB-8812-5BB4D83AAC6A}" dt="2026-04-17T02:47:42.001" v="27" actId="1076"/>
+          <ac:picMkLst>
+            <pc:docMk/>
+            <pc:sldMk cId="1102067116" sldId="263"/>
+            <ac:picMk id="6" creationId="{00000000-0000-0000-0000-000000000000}"/>
+          </ac:picMkLst>
+        </pc:picChg>
+      </pc:sldChg>
+      <pc:sldChg chg="addSp delSp modSp new mod">
+        <pc:chgData name="musukie52@gmail.com" userId="017bd91f96aa8751" providerId="LiveId" clId="{5B2C3894-F97E-4CAB-8812-5BB4D83AAC6A}" dt="2026-04-17T02:33:40.971" v="4" actId="1076"/>
+        <pc:sldMkLst>
+          <pc:docMk/>
+          <pc:sldMk cId="1384166840" sldId="264"/>
+        </pc:sldMkLst>
+        <pc:spChg chg="del">
+          <ac:chgData name="musukie52@gmail.com" userId="017bd91f96aa8751" providerId="LiveId" clId="{5B2C3894-F97E-4CAB-8812-5BB4D83AAC6A}" dt="2026-04-17T02:33:36.893" v="1" actId="478"/>
+          <ac:spMkLst>
+            <pc:docMk/>
+            <pc:sldMk cId="1384166840" sldId="264"/>
+            <ac:spMk id="2" creationId="{C8AA83F4-4D7E-1AE4-2924-7681C5D3F8B3}"/>
+          </ac:spMkLst>
+        </pc:spChg>
+        <pc:spChg chg="del">
+          <ac:chgData name="musukie52@gmail.com" userId="017bd91f96aa8751" providerId="LiveId" clId="{5B2C3894-F97E-4CAB-8812-5BB4D83AAC6A}" dt="2026-04-17T02:33:36.893" v="1" actId="478"/>
+          <ac:spMkLst>
+            <pc:docMk/>
+            <pc:sldMk cId="1384166840" sldId="264"/>
+            <ac:spMk id="3" creationId="{F8684E57-7C61-654C-8E5C-F32F4D3D5A3D}"/>
+          </ac:spMkLst>
+        </pc:spChg>
+        <pc:picChg chg="add mod">
+          <ac:chgData name="musukie52@gmail.com" userId="017bd91f96aa8751" providerId="LiveId" clId="{5B2C3894-F97E-4CAB-8812-5BB4D83AAC6A}" dt="2026-04-17T02:33:40.971" v="4" actId="1076"/>
+          <ac:picMkLst>
+            <pc:docMk/>
+            <pc:sldMk cId="1384166840" sldId="264"/>
+            <ac:picMk id="5" creationId="{ECCEBF64-9B3F-B976-F13F-1254C6BD7FEA}"/>
+          </ac:picMkLst>
+        </pc:picChg>
+      </pc:sldChg>
+      <pc:sldChg chg="addSp delSp new del mod">
+        <pc:chgData name="musukie52@gmail.com" userId="017bd91f96aa8751" providerId="LiveId" clId="{5B2C3894-F97E-4CAB-8812-5BB4D83AAC6A}" dt="2026-04-17T02:34:33.240" v="8" actId="47"/>
+        <pc:sldMkLst>
+          <pc:docMk/>
+          <pc:sldMk cId="198791128" sldId="265"/>
+        </pc:sldMkLst>
+        <pc:spChg chg="del">
+          <ac:chgData name="musukie52@gmail.com" userId="017bd91f96aa8751" providerId="LiveId" clId="{5B2C3894-F97E-4CAB-8812-5BB4D83AAC6A}" dt="2026-04-17T02:34:22.409" v="6" actId="478"/>
+          <ac:spMkLst>
+            <pc:docMk/>
+            <pc:sldMk cId="198791128" sldId="265"/>
+            <ac:spMk id="2" creationId="{A0E24753-B223-0BF7-9C63-993BCF37E805}"/>
+          </ac:spMkLst>
+        </pc:spChg>
+        <pc:spChg chg="del">
+          <ac:chgData name="musukie52@gmail.com" userId="017bd91f96aa8751" providerId="LiveId" clId="{5B2C3894-F97E-4CAB-8812-5BB4D83AAC6A}" dt="2026-04-17T02:34:22.409" v="6" actId="478"/>
+          <ac:spMkLst>
+            <pc:docMk/>
+            <pc:sldMk cId="198791128" sldId="265"/>
+            <ac:spMk id="3" creationId="{4D55FED4-E0B5-8D81-B749-1722D6CC6334}"/>
+          </ac:spMkLst>
+        </pc:spChg>
+        <pc:spChg chg="add">
+          <ac:chgData name="musukie52@gmail.com" userId="017bd91f96aa8751" providerId="LiveId" clId="{5B2C3894-F97E-4CAB-8812-5BB4D83AAC6A}" dt="2026-04-17T02:34:23.272" v="7" actId="22"/>
+          <ac:spMkLst>
+            <pc:docMk/>
+            <pc:sldMk cId="198791128" sldId="265"/>
+            <ac:spMk id="5" creationId="{B628B201-1F03-3D67-7DE9-ABD3EF941E85}"/>
+          </ac:spMkLst>
+        </pc:spChg>
+      </pc:sldChg>
+      <pc:sldChg chg="addSp delSp new mod">
+        <pc:chgData name="musukie52@gmail.com" userId="017bd91f96aa8751" providerId="LiveId" clId="{5B2C3894-F97E-4CAB-8812-5BB4D83AAC6A}" dt="2026-04-17T02:34:54.430" v="11" actId="22"/>
+        <pc:sldMkLst>
+          <pc:docMk/>
+          <pc:sldMk cId="2504027400" sldId="265"/>
+        </pc:sldMkLst>
+        <pc:spChg chg="del">
+          <ac:chgData name="musukie52@gmail.com" userId="017bd91f96aa8751" providerId="LiveId" clId="{5B2C3894-F97E-4CAB-8812-5BB4D83AAC6A}" dt="2026-04-17T02:34:54.112" v="10" actId="478"/>
+          <ac:spMkLst>
+            <pc:docMk/>
+            <pc:sldMk cId="2504027400" sldId="265"/>
+            <ac:spMk id="2" creationId="{F2E7AF28-F6F0-89B7-E70F-9AD7CFE25377}"/>
+          </ac:spMkLst>
+        </pc:spChg>
+        <pc:spChg chg="del">
+          <ac:chgData name="musukie52@gmail.com" userId="017bd91f96aa8751" providerId="LiveId" clId="{5B2C3894-F97E-4CAB-8812-5BB4D83AAC6A}" dt="2026-04-17T02:34:54.112" v="10" actId="478"/>
+          <ac:spMkLst>
+            <pc:docMk/>
+            <pc:sldMk cId="2504027400" sldId="265"/>
+            <ac:spMk id="3" creationId="{304E4FCC-0C65-4D58-226B-1AF5BF6284CC}"/>
+          </ac:spMkLst>
+        </pc:spChg>
+        <pc:picChg chg="add">
+          <ac:chgData name="musukie52@gmail.com" userId="017bd91f96aa8751" providerId="LiveId" clId="{5B2C3894-F97E-4CAB-8812-5BB4D83AAC6A}" dt="2026-04-17T02:34:54.430" v="11" actId="22"/>
+          <ac:picMkLst>
+            <pc:docMk/>
+            <pc:sldMk cId="2504027400" sldId="265"/>
+            <ac:picMk id="5" creationId="{56CBF099-E19A-0115-F5C2-F6949C71F6CE}"/>
+          </ac:picMkLst>
+        </pc:picChg>
+      </pc:sldChg>
+      <pc:sldChg chg="addSp new mod">
+        <pc:chgData name="musukie52@gmail.com" userId="017bd91f96aa8751" providerId="LiveId" clId="{5B2C3894-F97E-4CAB-8812-5BB4D83AAC6A}" dt="2026-04-17T02:44:56.304" v="13" actId="22"/>
+        <pc:sldMkLst>
+          <pc:docMk/>
+          <pc:sldMk cId="1102019427" sldId="266"/>
+        </pc:sldMkLst>
+        <pc:picChg chg="add">
+          <ac:chgData name="musukie52@gmail.com" userId="017bd91f96aa8751" providerId="LiveId" clId="{5B2C3894-F97E-4CAB-8812-5BB4D83AAC6A}" dt="2026-04-17T02:44:56.304" v="13" actId="22"/>
+          <ac:picMkLst>
+            <pc:docMk/>
+            <pc:sldMk cId="1102019427" sldId="266"/>
+            <ac:picMk id="5" creationId="{2C0824AB-8A4D-1985-76E5-549873A22BFA}"/>
+          </ac:picMkLst>
+        </pc:picChg>
+      </pc:sldChg>
+      <pc:sldChg chg="addSp delSp new mod">
+        <pc:chgData name="musukie52@gmail.com" userId="017bd91f96aa8751" providerId="LiveId" clId="{5B2C3894-F97E-4CAB-8812-5BB4D83AAC6A}" dt="2026-04-17T02:46:08.967" v="19" actId="22"/>
+        <pc:sldMkLst>
+          <pc:docMk/>
+          <pc:sldMk cId="1238072532" sldId="267"/>
+        </pc:sldMkLst>
+        <pc:picChg chg="add">
+          <ac:chgData name="musukie52@gmail.com" userId="017bd91f96aa8751" providerId="LiveId" clId="{5B2C3894-F97E-4CAB-8812-5BB4D83AAC6A}" dt="2026-04-17T02:45:11.761" v="15" actId="22"/>
+          <ac:picMkLst>
+            <pc:docMk/>
+            <pc:sldMk cId="1238072532" sldId="267"/>
+            <ac:picMk id="5" creationId="{5F6C3D93-3174-C44C-31D2-9CA93318E92F}"/>
+          </ac:picMkLst>
+        </pc:picChg>
+        <pc:picChg chg="add del">
+          <ac:chgData name="musukie52@gmail.com" userId="017bd91f96aa8751" providerId="LiveId" clId="{5B2C3894-F97E-4CAB-8812-5BB4D83AAC6A}" dt="2026-04-17T02:46:08.967" v="19" actId="22"/>
+          <ac:picMkLst>
+            <pc:docMk/>
+            <pc:sldMk cId="1238072532" sldId="267"/>
+            <ac:picMk id="7" creationId="{F6D22FE8-4FD0-D96E-4DBA-446FBD3591B7}"/>
+          </ac:picMkLst>
+        </pc:picChg>
+      </pc:sldChg>
+      <pc:sldChg chg="addSp new mod">
+        <pc:chgData name="musukie52@gmail.com" userId="017bd91f96aa8751" providerId="LiveId" clId="{5B2C3894-F97E-4CAB-8812-5BB4D83AAC6A}" dt="2026-04-17T02:45:44.927" v="17" actId="22"/>
+        <pc:sldMkLst>
+          <pc:docMk/>
+          <pc:sldMk cId="473193607" sldId="268"/>
+        </pc:sldMkLst>
+        <pc:picChg chg="add">
+          <ac:chgData name="musukie52@gmail.com" userId="017bd91f96aa8751" providerId="LiveId" clId="{5B2C3894-F97E-4CAB-8812-5BB4D83AAC6A}" dt="2026-04-17T02:45:44.927" v="17" actId="22"/>
+          <ac:picMkLst>
+            <pc:docMk/>
+            <pc:sldMk cId="473193607" sldId="268"/>
+            <ac:picMk id="5" creationId="{B04A8D6E-AEFB-BE90-2C53-0BA7AF7D9663}"/>
+          </ac:picMkLst>
+        </pc:picChg>
+      </pc:sldChg>
+      <pc:sldChg chg="addSp new mod">
+        <pc:chgData name="musukie52@gmail.com" userId="017bd91f96aa8751" providerId="LiveId" clId="{5B2C3894-F97E-4CAB-8812-5BB4D83AAC6A}" dt="2026-04-17T02:46:11.176" v="21" actId="22"/>
+        <pc:sldMkLst>
+          <pc:docMk/>
+          <pc:sldMk cId="3945875900" sldId="269"/>
+        </pc:sldMkLst>
+        <pc:picChg chg="add">
+          <ac:chgData name="musukie52@gmail.com" userId="017bd91f96aa8751" providerId="LiveId" clId="{5B2C3894-F97E-4CAB-8812-5BB4D83AAC6A}" dt="2026-04-17T02:46:11.176" v="21" actId="22"/>
+          <ac:picMkLst>
+            <pc:docMk/>
+            <pc:sldMk cId="3945875900" sldId="269"/>
+            <ac:picMk id="5" creationId="{E5ACF3A5-3A3B-D428-72B6-E8891C5385CE}"/>
+          </ac:picMkLst>
+        </pc:picChg>
+      </pc:sldChg>
+      <pc:sldChg chg="addSp delSp modSp new mod">
+        <pc:chgData name="musukie52@gmail.com" userId="017bd91f96aa8751" providerId="LiveId" clId="{5B2C3894-F97E-4CAB-8812-5BB4D83AAC6A}" dt="2026-04-17T04:19:11.713" v="1452" actId="1076"/>
+        <pc:sldMkLst>
+          <pc:docMk/>
+          <pc:sldMk cId="1648487806" sldId="270"/>
+        </pc:sldMkLst>
+        <pc:spChg chg="del">
+          <ac:chgData name="musukie52@gmail.com" userId="017bd91f96aa8751" providerId="LiveId" clId="{5B2C3894-F97E-4CAB-8812-5BB4D83AAC6A}" dt="2026-04-17T04:10:46.872" v="516" actId="478"/>
+          <ac:spMkLst>
+            <pc:docMk/>
+            <pc:sldMk cId="1648487806" sldId="270"/>
+            <ac:spMk id="2" creationId="{92FA9424-D627-B031-D547-BE05E55D9910}"/>
+          </ac:spMkLst>
+        </pc:spChg>
+        <pc:spChg chg="del">
+          <ac:chgData name="musukie52@gmail.com" userId="017bd91f96aa8751" providerId="LiveId" clId="{5B2C3894-F97E-4CAB-8812-5BB4D83AAC6A}" dt="2026-04-17T04:10:46.872" v="516" actId="478"/>
+          <ac:spMkLst>
+            <pc:docMk/>
+            <pc:sldMk cId="1648487806" sldId="270"/>
+            <ac:spMk id="3" creationId="{FB7AB4F1-49FE-6B3A-C940-40017CD709B3}"/>
+          </ac:spMkLst>
+        </pc:spChg>
+        <pc:graphicFrameChg chg="add del">
+          <ac:chgData name="musukie52@gmail.com" userId="017bd91f96aa8751" providerId="LiveId" clId="{5B2C3894-F97E-4CAB-8812-5BB4D83AAC6A}" dt="2026-04-17T04:10:53.990" v="518" actId="3680"/>
+          <ac:graphicFrameMkLst>
+            <pc:docMk/>
+            <pc:sldMk cId="1648487806" sldId="270"/>
+            <ac:graphicFrameMk id="4" creationId="{5E993548-1CAC-3928-D89A-D9F95659D64D}"/>
+          </ac:graphicFrameMkLst>
+        </pc:graphicFrameChg>
+        <pc:graphicFrameChg chg="add mod modGraphic">
+          <ac:chgData name="musukie52@gmail.com" userId="017bd91f96aa8751" providerId="LiveId" clId="{5B2C3894-F97E-4CAB-8812-5BB4D83AAC6A}" dt="2026-04-17T04:19:11.713" v="1452" actId="1076"/>
+          <ac:graphicFrameMkLst>
+            <pc:docMk/>
+            <pc:sldMk cId="1648487806" sldId="270"/>
+            <ac:graphicFrameMk id="5" creationId="{C904DAA2-1935-8EEF-3078-BA0B589DD562}"/>
+          </ac:graphicFrameMkLst>
+        </pc:graphicFrameChg>
+        <pc:picChg chg="add del mod">
+          <ac:chgData name="musukie52@gmail.com" userId="017bd91f96aa8751" providerId="LiveId" clId="{5B2C3894-F97E-4CAB-8812-5BB4D83AAC6A}" dt="2026-04-17T04:16:14.531" v="1235" actId="478"/>
+          <ac:picMkLst>
+            <pc:docMk/>
+            <pc:sldMk cId="1648487806" sldId="270"/>
+            <ac:picMk id="6" creationId="{264C48D4-C573-38B0-FCB7-926EACD0AA91}"/>
+          </ac:picMkLst>
+        </pc:picChg>
+        <pc:picChg chg="add del mod">
+          <ac:chgData name="musukie52@gmail.com" userId="017bd91f96aa8751" providerId="LiveId" clId="{5B2C3894-F97E-4CAB-8812-5BB4D83AAC6A}" dt="2026-04-17T04:17:03.633" v="1425" actId="478"/>
+          <ac:picMkLst>
+            <pc:docMk/>
+            <pc:sldMk cId="1648487806" sldId="270"/>
+            <ac:picMk id="7" creationId="{5DEB984B-D71C-BAD9-8C17-4B2F28873DCA}"/>
+          </ac:picMkLst>
+        </pc:picChg>
+        <pc:picChg chg="add mod">
+          <ac:chgData name="musukie52@gmail.com" userId="017bd91f96aa8751" providerId="LiveId" clId="{5B2C3894-F97E-4CAB-8812-5BB4D83AAC6A}" dt="2026-04-17T04:19:11.713" v="1452" actId="1076"/>
+          <ac:picMkLst>
+            <pc:docMk/>
+            <pc:sldMk cId="1648487806" sldId="270"/>
+            <ac:picMk id="8" creationId="{19B34CCB-9FB9-9A22-0438-0FF6DC3FDBAE}"/>
+          </ac:picMkLst>
+        </pc:picChg>
+        <pc:picChg chg="add mod">
+          <ac:chgData name="musukie52@gmail.com" userId="017bd91f96aa8751" providerId="LiveId" clId="{5B2C3894-F97E-4CAB-8812-5BB4D83AAC6A}" dt="2026-04-17T04:19:11.713" v="1452" actId="1076"/>
+          <ac:picMkLst>
+            <pc:docMk/>
+            <pc:sldMk cId="1648487806" sldId="270"/>
+            <ac:picMk id="9" creationId="{7629C32B-1AFA-68C8-8F4E-2D1E7E139F5D}"/>
+          </ac:picMkLst>
+        </pc:picChg>
+      </pc:sldChg>
+    </pc:docChg>
+  </pc:docChgLst>
+</pc:chgInfo>
 </file>
 
 <file path=ppt/slideLayouts/slideLayout1.xml><?xml version="1.0" encoding="utf-8"?>
@@ -155,10 +460,9 @@
           </a:lstStyle>
           <a:p>
             <a:r>
-              <a:rPr lang="ko-KR" altLang="en-US" smtClean="0"/>
+              <a:rPr lang="ko-KR" altLang="en-US"/>
               <a:t>마스터 제목 스타일 편집</a:t>
             </a:r>
-            <a:endParaRPr lang="ko-KR" altLang="en-US"/>
           </a:p>
         </p:txBody>
       </p:sp>
@@ -220,10 +524,9 @@
           </a:lstStyle>
           <a:p>
             <a:r>
-              <a:rPr lang="ko-KR" altLang="en-US" smtClean="0"/>
+              <a:rPr lang="ko-KR" altLang="en-US"/>
               <a:t>클릭하여 마스터 부제목 스타일 편집</a:t>
             </a:r>
-            <a:endParaRPr lang="ko-KR" altLang="en-US"/>
           </a:p>
         </p:txBody>
       </p:sp>
@@ -244,7 +547,7 @@
           <a:p>
             <a:fld id="{2C6C67B3-2F20-4398-B65A-450AEFDBBFDE}" type="datetimeFigureOut">
               <a:rPr lang="ko-KR" altLang="en-US" smtClean="0"/>
-              <a:t>2026-04-16</a:t>
+              <a:t>2026-04-17</a:t>
             </a:fld>
             <a:endParaRPr lang="ko-KR" altLang="en-US"/>
           </a:p>
@@ -338,10 +641,9 @@
           <a:lstStyle/>
           <a:p>
             <a:r>
-              <a:rPr lang="ko-KR" altLang="en-US" smtClean="0"/>
+              <a:rPr lang="ko-KR" altLang="en-US"/>
               <a:t>마스터 제목 스타일 편집</a:t>
             </a:r>
-            <a:endParaRPr lang="ko-KR" altLang="en-US"/>
           </a:p>
         </p:txBody>
       </p:sp>
@@ -362,38 +664,37 @@
           <a:p>
             <a:pPr lvl="0"/>
             <a:r>
-              <a:rPr lang="ko-KR" altLang="en-US" smtClean="0"/>
+              <a:rPr lang="ko-KR" altLang="en-US"/>
               <a:t>마스터 텍스트 스타일 편집</a:t>
             </a:r>
           </a:p>
           <a:p>
             <a:pPr lvl="1"/>
             <a:r>
-              <a:rPr lang="ko-KR" altLang="en-US" smtClean="0"/>
+              <a:rPr lang="ko-KR" altLang="en-US"/>
               <a:t>둘째 수준</a:t>
             </a:r>
           </a:p>
           <a:p>
             <a:pPr lvl="2"/>
             <a:r>
-              <a:rPr lang="ko-KR" altLang="en-US" smtClean="0"/>
+              <a:rPr lang="ko-KR" altLang="en-US"/>
               <a:t>셋째 수준</a:t>
             </a:r>
           </a:p>
           <a:p>
             <a:pPr lvl="3"/>
             <a:r>
-              <a:rPr lang="ko-KR" altLang="en-US" smtClean="0"/>
+              <a:rPr lang="ko-KR" altLang="en-US"/>
               <a:t>넷째 수준</a:t>
             </a:r>
           </a:p>
           <a:p>
             <a:pPr lvl="4"/>
             <a:r>
-              <a:rPr lang="ko-KR" altLang="en-US" smtClean="0"/>
+              <a:rPr lang="ko-KR" altLang="en-US"/>
               <a:t>다섯째 수준</a:t>
             </a:r>
-            <a:endParaRPr lang="ko-KR" altLang="en-US"/>
           </a:p>
         </p:txBody>
       </p:sp>
@@ -414,7 +715,7 @@
           <a:p>
             <a:fld id="{2C6C67B3-2F20-4398-B65A-450AEFDBBFDE}" type="datetimeFigureOut">
               <a:rPr lang="ko-KR" altLang="en-US" smtClean="0"/>
-              <a:t>2026-04-16</a:t>
+              <a:t>2026-04-17</a:t>
             </a:fld>
             <a:endParaRPr lang="ko-KR" altLang="en-US"/>
           </a:p>
@@ -513,10 +814,9 @@
           <a:lstStyle/>
           <a:p>
             <a:r>
-              <a:rPr lang="ko-KR" altLang="en-US" smtClean="0"/>
+              <a:rPr lang="ko-KR" altLang="en-US"/>
               <a:t>마스터 제목 스타일 편집</a:t>
             </a:r>
-            <a:endParaRPr lang="ko-KR" altLang="en-US"/>
           </a:p>
         </p:txBody>
       </p:sp>
@@ -542,38 +842,37 @@
           <a:p>
             <a:pPr lvl="0"/>
             <a:r>
-              <a:rPr lang="ko-KR" altLang="en-US" smtClean="0"/>
+              <a:rPr lang="ko-KR" altLang="en-US"/>
               <a:t>마스터 텍스트 스타일 편집</a:t>
             </a:r>
           </a:p>
           <a:p>
             <a:pPr lvl="1"/>
             <a:r>
-              <a:rPr lang="ko-KR" altLang="en-US" smtClean="0"/>
+              <a:rPr lang="ko-KR" altLang="en-US"/>
               <a:t>둘째 수준</a:t>
             </a:r>
           </a:p>
           <a:p>
             <a:pPr lvl="2"/>
             <a:r>
-              <a:rPr lang="ko-KR" altLang="en-US" smtClean="0"/>
+              <a:rPr lang="ko-KR" altLang="en-US"/>
               <a:t>셋째 수준</a:t>
             </a:r>
           </a:p>
           <a:p>
             <a:pPr lvl="3"/>
             <a:r>
-              <a:rPr lang="ko-KR" altLang="en-US" smtClean="0"/>
+              <a:rPr lang="ko-KR" altLang="en-US"/>
               <a:t>넷째 수준</a:t>
             </a:r>
           </a:p>
           <a:p>
             <a:pPr lvl="4"/>
             <a:r>
-              <a:rPr lang="ko-KR" altLang="en-US" smtClean="0"/>
+              <a:rPr lang="ko-KR" altLang="en-US"/>
               <a:t>다섯째 수준</a:t>
             </a:r>
-            <a:endParaRPr lang="ko-KR" altLang="en-US"/>
           </a:p>
         </p:txBody>
       </p:sp>
@@ -594,7 +893,7 @@
           <a:p>
             <a:fld id="{2C6C67B3-2F20-4398-B65A-450AEFDBBFDE}" type="datetimeFigureOut">
               <a:rPr lang="ko-KR" altLang="en-US" smtClean="0"/>
-              <a:t>2026-04-16</a:t>
+              <a:t>2026-04-17</a:t>
             </a:fld>
             <a:endParaRPr lang="ko-KR" altLang="en-US"/>
           </a:p>
@@ -688,10 +987,9 @@
           <a:lstStyle/>
           <a:p>
             <a:r>
-              <a:rPr lang="ko-KR" altLang="en-US" smtClean="0"/>
+              <a:rPr lang="ko-KR" altLang="en-US"/>
               <a:t>마스터 제목 스타일 편집</a:t>
             </a:r>
-            <a:endParaRPr lang="ko-KR" altLang="en-US"/>
           </a:p>
         </p:txBody>
       </p:sp>
@@ -712,38 +1010,37 @@
           <a:p>
             <a:pPr lvl="0"/>
             <a:r>
-              <a:rPr lang="ko-KR" altLang="en-US" smtClean="0"/>
+              <a:rPr lang="ko-KR" altLang="en-US"/>
               <a:t>마스터 텍스트 스타일 편집</a:t>
             </a:r>
           </a:p>
           <a:p>
             <a:pPr lvl="1"/>
             <a:r>
-              <a:rPr lang="ko-KR" altLang="en-US" smtClean="0"/>
+              <a:rPr lang="ko-KR" altLang="en-US"/>
               <a:t>둘째 수준</a:t>
             </a:r>
           </a:p>
           <a:p>
             <a:pPr lvl="2"/>
             <a:r>
-              <a:rPr lang="ko-KR" altLang="en-US" smtClean="0"/>
+              <a:rPr lang="ko-KR" altLang="en-US"/>
               <a:t>셋째 수준</a:t>
             </a:r>
           </a:p>
           <a:p>
             <a:pPr lvl="3"/>
             <a:r>
-              <a:rPr lang="ko-KR" altLang="en-US" smtClean="0"/>
+              <a:rPr lang="ko-KR" altLang="en-US"/>
               <a:t>넷째 수준</a:t>
             </a:r>
           </a:p>
           <a:p>
             <a:pPr lvl="4"/>
             <a:r>
-              <a:rPr lang="ko-KR" altLang="en-US" smtClean="0"/>
+              <a:rPr lang="ko-KR" altLang="en-US"/>
               <a:t>다섯째 수준</a:t>
             </a:r>
-            <a:endParaRPr lang="ko-KR" altLang="en-US"/>
           </a:p>
         </p:txBody>
       </p:sp>
@@ -764,7 +1061,7 @@
           <a:p>
             <a:fld id="{2C6C67B3-2F20-4398-B65A-450AEFDBBFDE}" type="datetimeFigureOut">
               <a:rPr lang="ko-KR" altLang="en-US" smtClean="0"/>
-              <a:t>2026-04-16</a:t>
+              <a:t>2026-04-17</a:t>
             </a:fld>
             <a:endParaRPr lang="ko-KR" altLang="en-US"/>
           </a:p>
@@ -867,10 +1164,9 @@
           </a:lstStyle>
           <a:p>
             <a:r>
-              <a:rPr lang="ko-KR" altLang="en-US" smtClean="0"/>
+              <a:rPr lang="ko-KR" altLang="en-US"/>
               <a:t>마스터 제목 스타일 편집</a:t>
             </a:r>
-            <a:endParaRPr lang="ko-KR" altLang="en-US"/>
           </a:p>
         </p:txBody>
       </p:sp>
@@ -987,7 +1283,7 @@
           <a:p>
             <a:pPr lvl="0"/>
             <a:r>
-              <a:rPr lang="ko-KR" altLang="en-US" smtClean="0"/>
+              <a:rPr lang="ko-KR" altLang="en-US"/>
               <a:t>마스터 텍스트 스타일 편집</a:t>
             </a:r>
           </a:p>
@@ -1010,7 +1306,7 @@
           <a:p>
             <a:fld id="{2C6C67B3-2F20-4398-B65A-450AEFDBBFDE}" type="datetimeFigureOut">
               <a:rPr lang="ko-KR" altLang="en-US" smtClean="0"/>
-              <a:t>2026-04-16</a:t>
+              <a:t>2026-04-17</a:t>
             </a:fld>
             <a:endParaRPr lang="ko-KR" altLang="en-US"/>
           </a:p>
@@ -1104,10 +1400,9 @@
           <a:lstStyle/>
           <a:p>
             <a:r>
-              <a:rPr lang="ko-KR" altLang="en-US" smtClean="0"/>
+              <a:rPr lang="ko-KR" altLang="en-US"/>
               <a:t>마스터 제목 스타일 편집</a:t>
             </a:r>
-            <a:endParaRPr lang="ko-KR" altLang="en-US"/>
           </a:p>
         </p:txBody>
       </p:sp>
@@ -1133,38 +1428,37 @@
           <a:p>
             <a:pPr lvl="0"/>
             <a:r>
-              <a:rPr lang="ko-KR" altLang="en-US" smtClean="0"/>
+              <a:rPr lang="ko-KR" altLang="en-US"/>
               <a:t>마스터 텍스트 스타일 편집</a:t>
             </a:r>
           </a:p>
           <a:p>
             <a:pPr lvl="1"/>
             <a:r>
-              <a:rPr lang="ko-KR" altLang="en-US" smtClean="0"/>
+              <a:rPr lang="ko-KR" altLang="en-US"/>
               <a:t>둘째 수준</a:t>
             </a:r>
           </a:p>
           <a:p>
             <a:pPr lvl="2"/>
             <a:r>
-              <a:rPr lang="ko-KR" altLang="en-US" smtClean="0"/>
+              <a:rPr lang="ko-KR" altLang="en-US"/>
               <a:t>셋째 수준</a:t>
             </a:r>
           </a:p>
           <a:p>
             <a:pPr lvl="3"/>
             <a:r>
-              <a:rPr lang="ko-KR" altLang="en-US" smtClean="0"/>
+              <a:rPr lang="ko-KR" altLang="en-US"/>
               <a:t>넷째 수준</a:t>
             </a:r>
           </a:p>
           <a:p>
             <a:pPr lvl="4"/>
             <a:r>
-              <a:rPr lang="ko-KR" altLang="en-US" smtClean="0"/>
+              <a:rPr lang="ko-KR" altLang="en-US"/>
               <a:t>다섯째 수준</a:t>
             </a:r>
-            <a:endParaRPr lang="ko-KR" altLang="en-US"/>
           </a:p>
         </p:txBody>
       </p:sp>
@@ -1190,38 +1484,37 @@
           <a:p>
             <a:pPr lvl="0"/>
             <a:r>
-              <a:rPr lang="ko-KR" altLang="en-US" smtClean="0"/>
+              <a:rPr lang="ko-KR" altLang="en-US"/>
               <a:t>마스터 텍스트 스타일 편집</a:t>
             </a:r>
           </a:p>
           <a:p>
             <a:pPr lvl="1"/>
             <a:r>
-              <a:rPr lang="ko-KR" altLang="en-US" smtClean="0"/>
+              <a:rPr lang="ko-KR" altLang="en-US"/>
               <a:t>둘째 수준</a:t>
             </a:r>
           </a:p>
           <a:p>
             <a:pPr lvl="2"/>
             <a:r>
-              <a:rPr lang="ko-KR" altLang="en-US" smtClean="0"/>
+              <a:rPr lang="ko-KR" altLang="en-US"/>
               <a:t>셋째 수준</a:t>
             </a:r>
           </a:p>
           <a:p>
             <a:pPr lvl="3"/>
             <a:r>
-              <a:rPr lang="ko-KR" altLang="en-US" smtClean="0"/>
+              <a:rPr lang="ko-KR" altLang="en-US"/>
               <a:t>넷째 수준</a:t>
             </a:r>
           </a:p>
           <a:p>
             <a:pPr lvl="4"/>
             <a:r>
-              <a:rPr lang="ko-KR" altLang="en-US" smtClean="0"/>
+              <a:rPr lang="ko-KR" altLang="en-US"/>
               <a:t>다섯째 수준</a:t>
             </a:r>
-            <a:endParaRPr lang="ko-KR" altLang="en-US"/>
           </a:p>
         </p:txBody>
       </p:sp>
@@ -1242,7 +1535,7 @@
           <a:p>
             <a:fld id="{2C6C67B3-2F20-4398-B65A-450AEFDBBFDE}" type="datetimeFigureOut">
               <a:rPr lang="ko-KR" altLang="en-US" smtClean="0"/>
-              <a:t>2026-04-16</a:t>
+              <a:t>2026-04-17</a:t>
             </a:fld>
             <a:endParaRPr lang="ko-KR" altLang="en-US"/>
           </a:p>
@@ -1341,10 +1634,9 @@
           <a:lstStyle/>
           <a:p>
             <a:r>
-              <a:rPr lang="ko-KR" altLang="en-US" smtClean="0"/>
+              <a:rPr lang="ko-KR" altLang="en-US"/>
               <a:t>마스터 제목 스타일 편집</a:t>
             </a:r>
-            <a:endParaRPr lang="ko-KR" altLang="en-US"/>
           </a:p>
         </p:txBody>
       </p:sp>
@@ -1407,7 +1699,7 @@
           <a:p>
             <a:pPr lvl="0"/>
             <a:r>
-              <a:rPr lang="ko-KR" altLang="en-US" smtClean="0"/>
+              <a:rPr lang="ko-KR" altLang="en-US"/>
               <a:t>마스터 텍스트 스타일 편집</a:t>
             </a:r>
           </a:p>
@@ -1435,38 +1727,37 @@
           <a:p>
             <a:pPr lvl="0"/>
             <a:r>
-              <a:rPr lang="ko-KR" altLang="en-US" smtClean="0"/>
+              <a:rPr lang="ko-KR" altLang="en-US"/>
               <a:t>마스터 텍스트 스타일 편집</a:t>
             </a:r>
           </a:p>
           <a:p>
             <a:pPr lvl="1"/>
             <a:r>
-              <a:rPr lang="ko-KR" altLang="en-US" smtClean="0"/>
+              <a:rPr lang="ko-KR" altLang="en-US"/>
               <a:t>둘째 수준</a:t>
             </a:r>
           </a:p>
           <a:p>
             <a:pPr lvl="2"/>
             <a:r>
-              <a:rPr lang="ko-KR" altLang="en-US" smtClean="0"/>
+              <a:rPr lang="ko-KR" altLang="en-US"/>
               <a:t>셋째 수준</a:t>
             </a:r>
           </a:p>
           <a:p>
             <a:pPr lvl="3"/>
             <a:r>
-              <a:rPr lang="ko-KR" altLang="en-US" smtClean="0"/>
+              <a:rPr lang="ko-KR" altLang="en-US"/>
               <a:t>넷째 수준</a:t>
             </a:r>
           </a:p>
           <a:p>
             <a:pPr lvl="4"/>
             <a:r>
-              <a:rPr lang="ko-KR" altLang="en-US" smtClean="0"/>
+              <a:rPr lang="ko-KR" altLang="en-US"/>
               <a:t>다섯째 수준</a:t>
             </a:r>
-            <a:endParaRPr lang="ko-KR" altLang="en-US"/>
           </a:p>
         </p:txBody>
       </p:sp>
@@ -1529,7 +1820,7 @@
           <a:p>
             <a:pPr lvl="0"/>
             <a:r>
-              <a:rPr lang="ko-KR" altLang="en-US" smtClean="0"/>
+              <a:rPr lang="ko-KR" altLang="en-US"/>
               <a:t>마스터 텍스트 스타일 편집</a:t>
             </a:r>
           </a:p>
@@ -1557,38 +1848,37 @@
           <a:p>
             <a:pPr lvl="0"/>
             <a:r>
-              <a:rPr lang="ko-KR" altLang="en-US" smtClean="0"/>
+              <a:rPr lang="ko-KR" altLang="en-US"/>
               <a:t>마스터 텍스트 스타일 편집</a:t>
             </a:r>
           </a:p>
           <a:p>
             <a:pPr lvl="1"/>
             <a:r>
-              <a:rPr lang="ko-KR" altLang="en-US" smtClean="0"/>
+              <a:rPr lang="ko-KR" altLang="en-US"/>
               <a:t>둘째 수준</a:t>
             </a:r>
           </a:p>
           <a:p>
             <a:pPr lvl="2"/>
             <a:r>
-              <a:rPr lang="ko-KR" altLang="en-US" smtClean="0"/>
+              <a:rPr lang="ko-KR" altLang="en-US"/>
               <a:t>셋째 수준</a:t>
             </a:r>
           </a:p>
           <a:p>
             <a:pPr lvl="3"/>
             <a:r>
-              <a:rPr lang="ko-KR" altLang="en-US" smtClean="0"/>
+              <a:rPr lang="ko-KR" altLang="en-US"/>
               <a:t>넷째 수준</a:t>
             </a:r>
           </a:p>
           <a:p>
             <a:pPr lvl="4"/>
             <a:r>
-              <a:rPr lang="ko-KR" altLang="en-US" smtClean="0"/>
+              <a:rPr lang="ko-KR" altLang="en-US"/>
               <a:t>다섯째 수준</a:t>
             </a:r>
-            <a:endParaRPr lang="ko-KR" altLang="en-US"/>
           </a:p>
         </p:txBody>
       </p:sp>
@@ -1609,7 +1899,7 @@
           <a:p>
             <a:fld id="{2C6C67B3-2F20-4398-B65A-450AEFDBBFDE}" type="datetimeFigureOut">
               <a:rPr lang="ko-KR" altLang="en-US" smtClean="0"/>
-              <a:t>2026-04-16</a:t>
+              <a:t>2026-04-17</a:t>
             </a:fld>
             <a:endParaRPr lang="ko-KR" altLang="en-US"/>
           </a:p>
@@ -1703,10 +1993,9 @@
           <a:lstStyle/>
           <a:p>
             <a:r>
-              <a:rPr lang="ko-KR" altLang="en-US" smtClean="0"/>
+              <a:rPr lang="ko-KR" altLang="en-US"/>
               <a:t>마스터 제목 스타일 편집</a:t>
             </a:r>
-            <a:endParaRPr lang="ko-KR" altLang="en-US"/>
           </a:p>
         </p:txBody>
       </p:sp>
@@ -1727,7 +2016,7 @@
           <a:p>
             <a:fld id="{2C6C67B3-2F20-4398-B65A-450AEFDBBFDE}" type="datetimeFigureOut">
               <a:rPr lang="ko-KR" altLang="en-US" smtClean="0"/>
-              <a:t>2026-04-16</a:t>
+              <a:t>2026-04-17</a:t>
             </a:fld>
             <a:endParaRPr lang="ko-KR" altLang="en-US"/>
           </a:p>
@@ -1822,7 +2111,7 @@
           <a:p>
             <a:fld id="{2C6C67B3-2F20-4398-B65A-450AEFDBBFDE}" type="datetimeFigureOut">
               <a:rPr lang="ko-KR" altLang="en-US" smtClean="0"/>
-              <a:t>2026-04-16</a:t>
+              <a:t>2026-04-17</a:t>
             </a:fld>
             <a:endParaRPr lang="ko-KR" altLang="en-US"/>
           </a:p>
@@ -1925,10 +2214,9 @@
           </a:lstStyle>
           <a:p>
             <a:r>
-              <a:rPr lang="ko-KR" altLang="en-US" smtClean="0"/>
+              <a:rPr lang="ko-KR" altLang="en-US"/>
               <a:t>마스터 제목 스타일 편집</a:t>
             </a:r>
-            <a:endParaRPr lang="ko-KR" altLang="en-US"/>
           </a:p>
         </p:txBody>
       </p:sp>
@@ -1982,38 +2270,37 @@
           <a:p>
             <a:pPr lvl="0"/>
             <a:r>
-              <a:rPr lang="ko-KR" altLang="en-US" smtClean="0"/>
+              <a:rPr lang="ko-KR" altLang="en-US"/>
               <a:t>마스터 텍스트 스타일 편집</a:t>
             </a:r>
           </a:p>
           <a:p>
             <a:pPr lvl="1"/>
             <a:r>
-              <a:rPr lang="ko-KR" altLang="en-US" smtClean="0"/>
+              <a:rPr lang="ko-KR" altLang="en-US"/>
               <a:t>둘째 수준</a:t>
             </a:r>
           </a:p>
           <a:p>
             <a:pPr lvl="2"/>
             <a:r>
-              <a:rPr lang="ko-KR" altLang="en-US" smtClean="0"/>
+              <a:rPr lang="ko-KR" altLang="en-US"/>
               <a:t>셋째 수준</a:t>
             </a:r>
           </a:p>
           <a:p>
             <a:pPr lvl="3"/>
             <a:r>
-              <a:rPr lang="ko-KR" altLang="en-US" smtClean="0"/>
+              <a:rPr lang="ko-KR" altLang="en-US"/>
               <a:t>넷째 수준</a:t>
             </a:r>
           </a:p>
           <a:p>
             <a:pPr lvl="4"/>
             <a:r>
-              <a:rPr lang="ko-KR" altLang="en-US" smtClean="0"/>
+              <a:rPr lang="ko-KR" altLang="en-US"/>
               <a:t>다섯째 수준</a:t>
             </a:r>
-            <a:endParaRPr lang="ko-KR" altLang="en-US"/>
           </a:p>
         </p:txBody>
       </p:sp>
@@ -2076,7 +2363,7 @@
           <a:p>
             <a:pPr lvl="0"/>
             <a:r>
-              <a:rPr lang="ko-KR" altLang="en-US" smtClean="0"/>
+              <a:rPr lang="ko-KR" altLang="en-US"/>
               <a:t>마스터 텍스트 스타일 편집</a:t>
             </a:r>
           </a:p>
@@ -2099,7 +2386,7 @@
           <a:p>
             <a:fld id="{2C6C67B3-2F20-4398-B65A-450AEFDBBFDE}" type="datetimeFigureOut">
               <a:rPr lang="ko-KR" altLang="en-US" smtClean="0"/>
-              <a:t>2026-04-16</a:t>
+              <a:t>2026-04-17</a:t>
             </a:fld>
             <a:endParaRPr lang="ko-KR" altLang="en-US"/>
           </a:p>
@@ -2202,10 +2489,9 @@
           </a:lstStyle>
           <a:p>
             <a:r>
-              <a:rPr lang="ko-KR" altLang="en-US" smtClean="0"/>
+              <a:rPr lang="ko-KR" altLang="en-US"/>
               <a:t>마스터 제목 스타일 편집</a:t>
             </a:r>
-            <a:endParaRPr lang="ko-KR" altLang="en-US"/>
           </a:p>
         </p:txBody>
       </p:sp>
@@ -2329,7 +2615,7 @@
           <a:p>
             <a:pPr lvl="0"/>
             <a:r>
-              <a:rPr lang="ko-KR" altLang="en-US" smtClean="0"/>
+              <a:rPr lang="ko-KR" altLang="en-US"/>
               <a:t>마스터 텍스트 스타일 편집</a:t>
             </a:r>
           </a:p>
@@ -2352,7 +2638,7 @@
           <a:p>
             <a:fld id="{2C6C67B3-2F20-4398-B65A-450AEFDBBFDE}" type="datetimeFigureOut">
               <a:rPr lang="ko-KR" altLang="en-US" smtClean="0"/>
-              <a:t>2026-04-16</a:t>
+              <a:t>2026-04-17</a:t>
             </a:fld>
             <a:endParaRPr lang="ko-KR" altLang="en-US"/>
           </a:p>
@@ -2461,10 +2747,9 @@
           <a:lstStyle/>
           <a:p>
             <a:r>
-              <a:rPr lang="ko-KR" altLang="en-US" smtClean="0"/>
+              <a:rPr lang="ko-KR" altLang="en-US"/>
               <a:t>마스터 제목 스타일 편집</a:t>
             </a:r>
-            <a:endParaRPr lang="ko-KR" altLang="en-US"/>
           </a:p>
         </p:txBody>
       </p:sp>
@@ -2495,38 +2780,37 @@
           <a:p>
             <a:pPr lvl="0"/>
             <a:r>
-              <a:rPr lang="ko-KR" altLang="en-US" smtClean="0"/>
+              <a:rPr lang="ko-KR" altLang="en-US"/>
               <a:t>마스터 텍스트 스타일 편집</a:t>
             </a:r>
           </a:p>
           <a:p>
             <a:pPr lvl="1"/>
             <a:r>
-              <a:rPr lang="ko-KR" altLang="en-US" smtClean="0"/>
+              <a:rPr lang="ko-KR" altLang="en-US"/>
               <a:t>둘째 수준</a:t>
             </a:r>
           </a:p>
           <a:p>
             <a:pPr lvl="2"/>
             <a:r>
-              <a:rPr lang="ko-KR" altLang="en-US" smtClean="0"/>
+              <a:rPr lang="ko-KR" altLang="en-US"/>
               <a:t>셋째 수준</a:t>
             </a:r>
           </a:p>
           <a:p>
             <a:pPr lvl="3"/>
             <a:r>
-              <a:rPr lang="ko-KR" altLang="en-US" smtClean="0"/>
+              <a:rPr lang="ko-KR" altLang="en-US"/>
               <a:t>넷째 수준</a:t>
             </a:r>
           </a:p>
           <a:p>
             <a:pPr lvl="4"/>
             <a:r>
-              <a:rPr lang="ko-KR" altLang="en-US" smtClean="0"/>
+              <a:rPr lang="ko-KR" altLang="en-US"/>
               <a:t>다섯째 수준</a:t>
             </a:r>
-            <a:endParaRPr lang="ko-KR" altLang="en-US"/>
           </a:p>
         </p:txBody>
       </p:sp>
@@ -2565,7 +2849,7 @@
           <a:p>
             <a:fld id="{2C6C67B3-2F20-4398-B65A-450AEFDBBFDE}" type="datetimeFigureOut">
               <a:rPr lang="ko-KR" altLang="en-US" smtClean="0"/>
-              <a:t>2026-04-16</a:t>
+              <a:t>2026-04-17</a:t>
             </a:fld>
             <a:endParaRPr lang="ko-KR" altLang="en-US"/>
           </a:p>
@@ -3007,7 +3291,7 @@
 </p:sld>
 </file>
 
-<file path=ppt/slides/slide2.xml><?xml version="1.0" encoding="utf-8"?>
+<file path=ppt/slides/slide10.xml><?xml version="1.0" encoding="utf-8"?>
 <p:sld xmlns:a="http://schemas.openxmlformats.org/drawingml/2006/main" xmlns:r="http://schemas.openxmlformats.org/officeDocument/2006/relationships" xmlns:p="http://schemas.openxmlformats.org/presentationml/2006/main">
   <p:cSld>
     <p:spTree>
@@ -3026,7 +3310,13 @@
       </p:grpSpPr>
       <p:sp>
         <p:nvSpPr>
-          <p:cNvPr id="2" name="제목 1"/>
+          <p:cNvPr id="2" name="제목 1">
+            <a:extLst>
+              <a:ext uri="{FF2B5EF4-FFF2-40B4-BE49-F238E27FC236}">
+                <a16:creationId xmlns:a16="http://schemas.microsoft.com/office/drawing/2014/main" id="{BB605566-D56C-07AA-FDEE-2D11A9823450}"/>
+              </a:ext>
+            </a:extLst>
+          </p:cNvPr>
           <p:cNvSpPr>
             <a:spLocks noGrp="1"/>
           </p:cNvSpPr>
@@ -3036,26 +3326,22 @@
         </p:nvSpPr>
         <p:spPr/>
         <p:txBody>
-          <a:bodyPr>
-            <a:normAutofit/>
-          </a:bodyPr>
-          <a:lstStyle/>
-          <a:p>
-            <a:r>
-              <a:rPr lang="ko-KR" altLang="en-US" sz="4000" smtClean="0"/>
-              <a:t>우리는 없는 존재에게 설정값을 넣어야 한다</a:t>
-            </a:r>
-            <a:r>
-              <a:rPr lang="en-US" altLang="ko-KR" sz="4000" smtClean="0"/>
-              <a:t>.</a:t>
-            </a:r>
-            <a:endParaRPr lang="ko-KR" altLang="en-US" sz="4000"/>
-          </a:p>
-        </p:txBody>
-      </p:sp>
-      <p:sp>
-        <p:nvSpPr>
-          <p:cNvPr id="3" name="내용 개체 틀 2"/>
+          <a:bodyPr/>
+          <a:lstStyle/>
+          <a:p>
+            <a:endParaRPr lang="ko-KR" altLang="en-US"/>
+          </a:p>
+        </p:txBody>
+      </p:sp>
+      <p:sp>
+        <p:nvSpPr>
+          <p:cNvPr id="3" name="내용 개체 틀 2">
+            <a:extLst>
+              <a:ext uri="{FF2B5EF4-FFF2-40B4-BE49-F238E27FC236}">
+                <a16:creationId xmlns:a16="http://schemas.microsoft.com/office/drawing/2014/main" id="{BE73080D-9BD3-DE6A-F737-5DF4666ECEC3}"/>
+              </a:ext>
+            </a:extLst>
+          </p:cNvPr>
           <p:cNvSpPr>
             <a:spLocks noGrp="1"/>
           </p:cNvSpPr>
@@ -3068,62 +3354,44 @@
           <a:bodyPr/>
           <a:lstStyle/>
           <a:p>
-            <a:r>
-              <a:rPr lang="ko-KR" altLang="en-US" smtClean="0"/>
-              <a:t>설정값 </a:t>
-            </a:r>
-            <a:r>
-              <a:rPr lang="en-US" altLang="ko-KR" smtClean="0"/>
-              <a:t>=&gt; </a:t>
-            </a:r>
-            <a:r>
-              <a:rPr lang="ko-KR" altLang="en-US" b="1" smtClean="0"/>
-              <a:t>게임에 필요한 것</a:t>
-            </a:r>
-            <a:r>
-              <a:rPr lang="ko-KR" altLang="en-US" smtClean="0"/>
-              <a:t>이어야 한다</a:t>
-            </a:r>
-            <a:r>
-              <a:rPr lang="en-US" altLang="ko-KR" smtClean="0"/>
-              <a:t>.</a:t>
-            </a:r>
-          </a:p>
-          <a:p>
-            <a:endParaRPr lang="en-US" altLang="ko-KR" smtClean="0"/>
-          </a:p>
-          <a:p>
-            <a:r>
-              <a:rPr lang="ko-KR" altLang="en-US" smtClean="0"/>
-              <a:t>필요하지 않은 설정 인자는 넣을 필요 없다</a:t>
-            </a:r>
-            <a:r>
-              <a:rPr lang="en-US" altLang="ko-KR" smtClean="0"/>
-              <a:t>!</a:t>
-            </a:r>
-            <a:br>
-              <a:rPr lang="en-US" altLang="ko-KR" smtClean="0"/>
-            </a:br>
-            <a:r>
-              <a:rPr lang="ko-KR" altLang="en-US" smtClean="0"/>
-              <a:t>예</a:t>
-            </a:r>
-            <a:r>
-              <a:rPr lang="en-US" altLang="ko-KR" smtClean="0"/>
-              <a:t>) </a:t>
-            </a:r>
-            <a:r>
-              <a:rPr lang="ko-KR" altLang="en-US" smtClean="0"/>
-              <a:t>혈액형</a:t>
-            </a:r>
             <a:endParaRPr lang="ko-KR" altLang="en-US"/>
           </a:p>
         </p:txBody>
       </p:sp>
+      <p:pic>
+        <p:nvPicPr>
+          <p:cNvPr id="5" name="그림 4">
+            <a:extLst>
+              <a:ext uri="{FF2B5EF4-FFF2-40B4-BE49-F238E27FC236}">
+                <a16:creationId xmlns:a16="http://schemas.microsoft.com/office/drawing/2014/main" id="{5F6C3D93-3174-C44C-31D2-9CA93318E92F}"/>
+              </a:ext>
+            </a:extLst>
+          </p:cNvPr>
+          <p:cNvPicPr>
+            <a:picLocks noChangeAspect="1"/>
+          </p:cNvPicPr>
+          <p:nvPr/>
+        </p:nvPicPr>
+        <p:blipFill>
+          <a:blip r:embed="rId2"/>
+          <a:stretch>
+            <a:fillRect/>
+          </a:stretch>
+        </p:blipFill>
+        <p:spPr>
+          <a:xfrm>
+            <a:off x="0" y="1096595"/>
+            <a:ext cx="12192000" cy="4664810"/>
+          </a:xfrm>
+          <a:prstGeom prst="rect">
+            <a:avLst/>
+          </a:prstGeom>
+        </p:spPr>
+      </p:pic>
     </p:spTree>
     <p:extLst>
       <p:ext uri="{BB962C8B-B14F-4D97-AF65-F5344CB8AC3E}">
-        <p14:creationId xmlns:p14="http://schemas.microsoft.com/office/powerpoint/2010/main" val="2052281943"/>
+        <p14:creationId xmlns:p14="http://schemas.microsoft.com/office/powerpoint/2010/main" val="1238072532"/>
       </p:ext>
     </p:extLst>
   </p:cSld>
@@ -3133,7 +3401,7 @@
 </p:sld>
 </file>
 
-<file path=ppt/slides/slide3.xml><?xml version="1.0" encoding="utf-8"?>
+<file path=ppt/slides/slide11.xml><?xml version="1.0" encoding="utf-8"?>
 <p:sld xmlns:a="http://schemas.openxmlformats.org/drawingml/2006/main" xmlns:r="http://schemas.openxmlformats.org/officeDocument/2006/relationships" xmlns:p="http://schemas.openxmlformats.org/presentationml/2006/main">
   <p:cSld>
     <p:spTree>
@@ -3152,7 +3420,13 @@
       </p:grpSpPr>
       <p:sp>
         <p:nvSpPr>
-          <p:cNvPr id="2" name="제목 1"/>
+          <p:cNvPr id="2" name="제목 1">
+            <a:extLst>
+              <a:ext uri="{FF2B5EF4-FFF2-40B4-BE49-F238E27FC236}">
+                <a16:creationId xmlns:a16="http://schemas.microsoft.com/office/drawing/2014/main" id="{2C42520C-1DE2-70AB-DBA3-05689EA71008}"/>
+              </a:ext>
+            </a:extLst>
+          </p:cNvPr>
           <p:cNvSpPr>
             <a:spLocks noGrp="1"/>
           </p:cNvSpPr>
@@ -3165,17 +3439,19 @@
           <a:bodyPr/>
           <a:lstStyle/>
           <a:p>
-            <a:r>
-              <a:rPr lang="ko-KR" altLang="en-US" smtClean="0"/>
-              <a:t>해야할 것</a:t>
-            </a:r>
             <a:endParaRPr lang="ko-KR" altLang="en-US"/>
           </a:p>
         </p:txBody>
       </p:sp>
       <p:sp>
         <p:nvSpPr>
-          <p:cNvPr id="3" name="내용 개체 틀 2"/>
+          <p:cNvPr id="3" name="내용 개체 틀 2">
+            <a:extLst>
+              <a:ext uri="{FF2B5EF4-FFF2-40B4-BE49-F238E27FC236}">
+                <a16:creationId xmlns:a16="http://schemas.microsoft.com/office/drawing/2014/main" id="{ACC93143-E924-E176-2166-B51A01D5C554}"/>
+              </a:ext>
+            </a:extLst>
+          </p:cNvPr>
           <p:cNvSpPr>
             <a:spLocks noGrp="1"/>
           </p:cNvSpPr>
@@ -3183,53 +3459,49 @@
             <p:ph idx="1"/>
           </p:nvPr>
         </p:nvSpPr>
+        <p:spPr/>
+        <p:txBody>
+          <a:bodyPr/>
+          <a:lstStyle/>
+          <a:p>
+            <a:endParaRPr lang="ko-KR" altLang="en-US"/>
+          </a:p>
+        </p:txBody>
+      </p:sp>
+      <p:pic>
+        <p:nvPicPr>
+          <p:cNvPr id="5" name="그림 4">
+            <a:extLst>
+              <a:ext uri="{FF2B5EF4-FFF2-40B4-BE49-F238E27FC236}">
+                <a16:creationId xmlns:a16="http://schemas.microsoft.com/office/drawing/2014/main" id="{E5ACF3A5-3A3B-D428-72B6-E8891C5385CE}"/>
+              </a:ext>
+            </a:extLst>
+          </p:cNvPr>
+          <p:cNvPicPr>
+            <a:picLocks noChangeAspect="1"/>
+          </p:cNvPicPr>
+          <p:nvPr/>
+        </p:nvPicPr>
+        <p:blipFill>
+          <a:blip r:embed="rId2"/>
+          <a:stretch>
+            <a:fillRect/>
+          </a:stretch>
+        </p:blipFill>
         <p:spPr>
           <a:xfrm>
-            <a:off x="637309" y="1825625"/>
-            <a:ext cx="10917382" cy="4351338"/>
+            <a:off x="973156" y="0"/>
+            <a:ext cx="10245687" cy="6858000"/>
           </a:xfrm>
+          <a:prstGeom prst="rect">
+            <a:avLst/>
+          </a:prstGeom>
         </p:spPr>
-        <p:txBody>
-          <a:bodyPr/>
-          <a:lstStyle/>
-          <a:p>
-            <a:r>
-              <a:rPr lang="ko-KR" altLang="en-US" smtClean="0"/>
-              <a:t>캐릭터의 전신 이미지</a:t>
-            </a:r>
-            <a:endParaRPr lang="en-US" altLang="ko-KR" smtClean="0"/>
-          </a:p>
-          <a:p>
-            <a:r>
-              <a:rPr lang="ko-KR" altLang="en-US" smtClean="0"/>
-              <a:t>화살표 선과 글상자로 설정값들을 넣어보자</a:t>
-            </a:r>
-            <a:r>
-              <a:rPr lang="en-US" altLang="ko-KR" smtClean="0"/>
-              <a:t>.</a:t>
-            </a:r>
-          </a:p>
-          <a:p>
-            <a:r>
-              <a:rPr lang="ko-KR" altLang="en-US" smtClean="0"/>
-              <a:t>외형이 아니더라도</a:t>
-            </a:r>
-            <a:r>
-              <a:rPr lang="en-US" altLang="ko-KR" smtClean="0"/>
-              <a:t>, </a:t>
-            </a:r>
-            <a:r>
-              <a:rPr lang="ko-KR" altLang="en-US" smtClean="0"/>
-              <a:t>그 사람이 가지고 있는 것들에 대해 적어보자</a:t>
-            </a:r>
-            <a:endParaRPr lang="ko-KR" altLang="en-US"/>
-          </a:p>
-        </p:txBody>
-      </p:sp>
+      </p:pic>
     </p:spTree>
     <p:extLst>
       <p:ext uri="{BB962C8B-B14F-4D97-AF65-F5344CB8AC3E}">
-        <p14:creationId xmlns:p14="http://schemas.microsoft.com/office/powerpoint/2010/main" val="1804572676"/>
+        <p14:creationId xmlns:p14="http://schemas.microsoft.com/office/powerpoint/2010/main" val="3945875900"/>
       </p:ext>
     </p:extLst>
   </p:cSld>
@@ -3239,7 +3511,7 @@
 </p:sld>
 </file>
 
-<file path=ppt/slides/slide4.xml><?xml version="1.0" encoding="utf-8"?>
+<file path=ppt/slides/slide12.xml><?xml version="1.0" encoding="utf-8"?>
 <p:sld xmlns:a="http://schemas.openxmlformats.org/drawingml/2006/main" xmlns:r="http://schemas.openxmlformats.org/officeDocument/2006/relationships" xmlns:p="http://schemas.openxmlformats.org/presentationml/2006/main">
   <p:cSld>
     <p:spTree>
@@ -3256,6 +3528,60 @@
           <a:chExt cx="0" cy="0"/>
         </a:xfrm>
       </p:grpSpPr>
+      <p:pic>
+        <p:nvPicPr>
+          <p:cNvPr id="4" name="그림 3"/>
+          <p:cNvPicPr>
+            <a:picLocks noChangeAspect="1"/>
+          </p:cNvPicPr>
+          <p:nvPr/>
+        </p:nvPicPr>
+        <p:blipFill>
+          <a:blip r:embed="rId2"/>
+          <a:stretch>
+            <a:fillRect/>
+          </a:stretch>
+        </p:blipFill>
+        <p:spPr>
+          <a:xfrm>
+            <a:off x="266464" y="285751"/>
+            <a:ext cx="11659072" cy="6286498"/>
+          </a:xfrm>
+          <a:prstGeom prst="rect">
+            <a:avLst/>
+          </a:prstGeom>
+        </p:spPr>
+      </p:pic>
+    </p:spTree>
+    <p:extLst>
+      <p:ext uri="{BB962C8B-B14F-4D97-AF65-F5344CB8AC3E}">
+        <p14:creationId xmlns:p14="http://schemas.microsoft.com/office/powerpoint/2010/main" val="3570744376"/>
+      </p:ext>
+    </p:extLst>
+  </p:cSld>
+  <p:clrMapOvr>
+    <a:masterClrMapping/>
+  </p:clrMapOvr>
+</p:sld>
+</file>
+
+<file path=ppt/slides/slide13.xml><?xml version="1.0" encoding="utf-8"?>
+<p:sld xmlns:a="http://schemas.openxmlformats.org/drawingml/2006/main" xmlns:r="http://schemas.openxmlformats.org/officeDocument/2006/relationships" xmlns:p="http://schemas.openxmlformats.org/presentationml/2006/main">
+  <p:cSld>
+    <p:spTree>
+      <p:nvGrpSpPr>
+        <p:cNvPr id="1" name=""/>
+        <p:cNvGrpSpPr/>
+        <p:nvPr/>
+      </p:nvGrpSpPr>
+      <p:grpSpPr>
+        <a:xfrm>
+          <a:off x="0" y="0"/>
+          <a:ext cx="0" cy="0"/>
+          <a:chOff x="0" y="0"/>
+          <a:chExt cx="0" cy="0"/>
+        </a:xfrm>
+      </p:grpSpPr>
       <p:sp>
         <p:nvSpPr>
           <p:cNvPr id="4" name="TextBox 3"/>
@@ -3284,10 +3610,12 @@
               </a:lnSpc>
             </a:pPr>
             <a:r>
-              <a:rPr lang="ko-KR" altLang="en-US" sz="1500" smtClean="0"/>
+              <a:rPr lang="ko-KR" altLang="en-US" sz="1500">
+                <a:latin typeface="PF스타더스트" panose="03050601020101020101" pitchFamily="66" charset="-127"/>
+                <a:ea typeface="PF스타더스트" panose="03050601020101020101" pitchFamily="66" charset="-127"/>
+              </a:rPr>
               <a:t>남색 비니</a:t>
             </a:r>
-            <a:endParaRPr lang="ko-KR" altLang="en-US" sz="1500"/>
           </a:p>
         </p:txBody>
       </p:sp>
@@ -3300,7 +3628,7 @@
         <p:spPr>
           <a:xfrm>
             <a:off x="8265000" y="4987011"/>
-            <a:ext cx="3677064" cy="414024"/>
+            <a:ext cx="3677064" cy="461665"/>
           </a:xfrm>
           <a:prstGeom prst="rect">
             <a:avLst/>
@@ -3322,10 +3650,16 @@
               </a:lnSpc>
             </a:pPr>
             <a:r>
-              <a:rPr lang="ko-KR" altLang="en-US" sz="1600" smtClean="0"/>
+              <a:rPr lang="ko-KR" altLang="en-US" sz="1600">
+                <a:latin typeface="PF스타더스트" panose="03050601020101020101" pitchFamily="66" charset="-127"/>
+                <a:ea typeface="PF스타더스트" panose="03050601020101020101" pitchFamily="66" charset="-127"/>
+              </a:rPr>
               <a:t>메시지 말투를 여러 번 수정하는 습관</a:t>
             </a:r>
-            <a:endParaRPr lang="ko-KR" altLang="en-US" sz="1500"/>
+            <a:endParaRPr lang="ko-KR" altLang="en-US" sz="1500">
+              <a:latin typeface="PF스타더스트" panose="03050601020101020101" pitchFamily="66" charset="-127"/>
+              <a:ea typeface="PF스타더스트" panose="03050601020101020101" pitchFamily="66" charset="-127"/>
+            </a:endParaRPr>
           </a:p>
         </p:txBody>
       </p:sp>
@@ -3391,7 +3725,7 @@
         <p:spPr>
           <a:xfrm>
             <a:off x="7196328" y="4371221"/>
-            <a:ext cx="1068672" cy="822802"/>
+            <a:ext cx="1068672" cy="846623"/>
           </a:xfrm>
           <a:prstGeom prst="straightConnector1">
             <a:avLst/>
@@ -3450,10 +3784,12 @@
               </a:lnSpc>
             </a:pPr>
             <a:r>
-              <a:rPr lang="ko-KR" altLang="en-US" sz="1500" smtClean="0"/>
+              <a:rPr lang="ko-KR" altLang="en-US" sz="1500">
+                <a:latin typeface="PF스타더스트" panose="03050601020101020101" pitchFamily="66" charset="-127"/>
+                <a:ea typeface="PF스타더스트" panose="03050601020101020101" pitchFamily="66" charset="-127"/>
+              </a:rPr>
               <a:t>선한 인상의 미소</a:t>
             </a:r>
-            <a:endParaRPr lang="ko-KR" altLang="en-US" sz="1500"/>
           </a:p>
         </p:txBody>
       </p:sp>
@@ -3563,10 +3899,16 @@
               </a:lnSpc>
             </a:pPr>
             <a:r>
-              <a:rPr lang="ko-KR" altLang="en-US" sz="1600" smtClean="0"/>
+              <a:rPr lang="ko-KR" altLang="en-US" sz="1600">
+                <a:latin typeface="PF스타더스트" panose="03050601020101020101" pitchFamily="66" charset="-127"/>
+                <a:ea typeface="PF스타더스트" panose="03050601020101020101" pitchFamily="66" charset="-127"/>
+              </a:rPr>
               <a:t>활동이 편한</a:t>
             </a:r>
-            <a:endParaRPr lang="en-US" altLang="ko-KR" sz="1600" smtClean="0"/>
+            <a:endParaRPr lang="en-US" altLang="ko-KR" sz="1600">
+              <a:latin typeface="PF스타더스트" panose="03050601020101020101" pitchFamily="66" charset="-127"/>
+              <a:ea typeface="PF스타더스트" panose="03050601020101020101" pitchFamily="66" charset="-127"/>
+            </a:endParaRPr>
           </a:p>
           <a:p>
             <a:pPr>
@@ -3575,10 +3917,16 @@
               </a:lnSpc>
             </a:pPr>
             <a:r>
-              <a:rPr lang="ko-KR" altLang="en-US" sz="1600" smtClean="0"/>
+              <a:rPr lang="ko-KR" altLang="en-US" sz="1600">
+                <a:latin typeface="PF스타더스트" panose="03050601020101020101" pitchFamily="66" charset="-127"/>
+                <a:ea typeface="PF스타더스트" panose="03050601020101020101" pitchFamily="66" charset="-127"/>
+              </a:rPr>
               <a:t>캐주얼 차림</a:t>
             </a:r>
-            <a:endParaRPr lang="ko-KR" altLang="en-US" sz="1500"/>
+            <a:endParaRPr lang="ko-KR" altLang="en-US" sz="1500">
+              <a:latin typeface="PF스타더스트" panose="03050601020101020101" pitchFamily="66" charset="-127"/>
+              <a:ea typeface="PF스타더스트" panose="03050601020101020101" pitchFamily="66" charset="-127"/>
+            </a:endParaRPr>
           </a:p>
         </p:txBody>
       </p:sp>
@@ -3613,18 +3961,26 @@
               </a:lnSpc>
             </a:pPr>
             <a:r>
-              <a:rPr lang="ko-KR" altLang="en-US" sz="1500" smtClean="0"/>
+              <a:rPr lang="ko-KR" altLang="en-US" sz="1500">
+                <a:latin typeface="PF스타더스트" panose="03050601020101020101" pitchFamily="66" charset="-127"/>
+                <a:ea typeface="PF스타더스트" panose="03050601020101020101" pitchFamily="66" charset="-127"/>
+              </a:rPr>
               <a:t>‘좋은 사람’으로 보이고</a:t>
             </a:r>
             <a:r>
-              <a:rPr lang="en-US" altLang="ko-KR" sz="1500"/>
+              <a:rPr lang="en-US" altLang="ko-KR" sz="1500">
+                <a:latin typeface="PF스타더스트" panose="03050601020101020101" pitchFamily="66" charset="-127"/>
+                <a:ea typeface="PF스타더스트" panose="03050601020101020101" pitchFamily="66" charset="-127"/>
+              </a:rPr>
               <a:t> </a:t>
             </a:r>
             <a:r>
-              <a:rPr lang="ko-KR" altLang="en-US" sz="1500" smtClean="0"/>
+              <a:rPr lang="ko-KR" altLang="en-US" sz="1500">
+                <a:latin typeface="PF스타더스트" panose="03050601020101020101" pitchFamily="66" charset="-127"/>
+                <a:ea typeface="PF스타더스트" panose="03050601020101020101" pitchFamily="66" charset="-127"/>
+              </a:rPr>
               <a:t>싶어 하는 욕구</a:t>
             </a:r>
-            <a:endParaRPr lang="ko-KR" altLang="en-US" sz="1500"/>
           </a:p>
         </p:txBody>
       </p:sp>
@@ -3715,7 +4071,7 @@
         <p:spPr>
           <a:xfrm>
             <a:off x="8502744" y="3368280"/>
-            <a:ext cx="3134756" cy="393954"/>
+            <a:ext cx="3134756" cy="438582"/>
           </a:xfrm>
           <a:prstGeom prst="rect">
             <a:avLst/>
@@ -3737,18 +4093,26 @@
               </a:lnSpc>
             </a:pPr>
             <a:r>
-              <a:rPr lang="ko-KR" altLang="en-US" sz="1500" smtClean="0"/>
+              <a:rPr lang="ko-KR" altLang="en-US" sz="1500">
+                <a:latin typeface="PF스타더스트" panose="03050601020101020101" pitchFamily="66" charset="-127"/>
+                <a:ea typeface="PF스타더스트" panose="03050601020101020101" pitchFamily="66" charset="-127"/>
+              </a:rPr>
               <a:t>소지품을 넉넉히 챙겨</a:t>
             </a:r>
             <a:r>
-              <a:rPr lang="en-US" altLang="ko-KR" sz="1500"/>
+              <a:rPr lang="en-US" altLang="ko-KR" sz="1500">
+                <a:latin typeface="PF스타더스트" panose="03050601020101020101" pitchFamily="66" charset="-127"/>
+                <a:ea typeface="PF스타더스트" panose="03050601020101020101" pitchFamily="66" charset="-127"/>
+              </a:rPr>
               <a:t> </a:t>
             </a:r>
             <a:r>
-              <a:rPr lang="ko-KR" altLang="en-US" sz="1500" smtClean="0"/>
+              <a:rPr lang="ko-KR" altLang="en-US" sz="1500">
+                <a:latin typeface="PF스타더스트" panose="03050601020101020101" pitchFamily="66" charset="-127"/>
+                <a:ea typeface="PF스타더스트" panose="03050601020101020101" pitchFamily="66" charset="-127"/>
+              </a:rPr>
               <a:t>다니는 습관</a:t>
             </a:r>
-            <a:endParaRPr lang="ko-KR" altLang="en-US" sz="1500"/>
           </a:p>
         </p:txBody>
       </p:sp>
@@ -3763,7 +4127,7 @@
         <p:spPr>
           <a:xfrm>
             <a:off x="7443216" y="3300569"/>
-            <a:ext cx="1059528" cy="264688"/>
+            <a:ext cx="1059528" cy="287002"/>
           </a:xfrm>
           <a:prstGeom prst="straightConnector1">
             <a:avLst/>
@@ -3814,10 +4178,12 @@
           <a:lstStyle/>
           <a:p>
             <a:r>
-              <a:rPr lang="ko-KR" altLang="en-US" sz="3000" smtClean="0"/>
+              <a:rPr lang="ko-KR" altLang="en-US" sz="3000">
+                <a:latin typeface="PF스타더스트" panose="03050601020101020101" pitchFamily="66" charset="-127"/>
+                <a:ea typeface="PF스타더스트" panose="03050601020101020101" pitchFamily="66" charset="-127"/>
+              </a:rPr>
               <a:t>주인공 설정</a:t>
             </a:r>
-            <a:endParaRPr lang="ko-KR" altLang="en-US" sz="3000"/>
           </a:p>
         </p:txBody>
       </p:sp>
@@ -3825,6 +4191,1356 @@
     <p:extLst>
       <p:ext uri="{BB962C8B-B14F-4D97-AF65-F5344CB8AC3E}">
         <p14:creationId xmlns:p14="http://schemas.microsoft.com/office/powerpoint/2010/main" val="496147517"/>
+      </p:ext>
+    </p:extLst>
+  </p:cSld>
+  <p:clrMapOvr>
+    <a:masterClrMapping/>
+  </p:clrMapOvr>
+</p:sld>
+</file>
+
+<file path=ppt/slides/slide14.xml><?xml version="1.0" encoding="utf-8"?>
+<p:sld xmlns:a="http://schemas.openxmlformats.org/drawingml/2006/main" xmlns:r="http://schemas.openxmlformats.org/officeDocument/2006/relationships" xmlns:p="http://schemas.openxmlformats.org/presentationml/2006/main">
+  <p:cSld>
+    <p:spTree>
+      <p:nvGrpSpPr>
+        <p:cNvPr id="1" name=""/>
+        <p:cNvGrpSpPr/>
+        <p:nvPr/>
+      </p:nvGrpSpPr>
+      <p:grpSpPr>
+        <a:xfrm>
+          <a:off x="0" y="0"/>
+          <a:ext cx="0" cy="0"/>
+          <a:chOff x="0" y="0"/>
+          <a:chExt cx="0" cy="0"/>
+        </a:xfrm>
+      </p:grpSpPr>
+      <p:graphicFrame>
+        <p:nvGraphicFramePr>
+          <p:cNvPr id="5" name="표 4">
+            <a:extLst>
+              <a:ext uri="{FF2B5EF4-FFF2-40B4-BE49-F238E27FC236}">
+                <a16:creationId xmlns:a16="http://schemas.microsoft.com/office/drawing/2014/main" id="{C904DAA2-1935-8EEF-3078-BA0B589DD562}"/>
+              </a:ext>
+            </a:extLst>
+          </p:cNvPr>
+          <p:cNvGraphicFramePr>
+            <a:graphicFrameLocks noGrp="1"/>
+          </p:cNvGraphicFramePr>
+          <p:nvPr>
+            <p:extLst>
+              <p:ext uri="{D42A27DB-BD31-4B8C-83A1-F6EECF244321}">
+                <p14:modId xmlns:p14="http://schemas.microsoft.com/office/powerpoint/2010/main" val="3914696059"/>
+              </p:ext>
+            </p:extLst>
+          </p:nvPr>
+        </p:nvGraphicFramePr>
+        <p:xfrm>
+          <a:off x="2032000" y="361078"/>
+          <a:ext cx="8128000" cy="6061623"/>
+        </p:xfrm>
+        <a:graphic>
+          <a:graphicData uri="http://schemas.openxmlformats.org/drawingml/2006/table">
+            <a:tbl>
+              <a:tblPr firstRow="1" bandRow="1">
+                <a:tableStyleId>{0505E3EF-67EA-436B-97B2-0124C06EBD24}</a:tableStyleId>
+              </a:tblPr>
+              <a:tblGrid>
+                <a:gridCol w="1441493">
+                  <a:extLst>
+                    <a:ext uri="{9D8B030D-6E8A-4147-A177-3AD203B41FA5}">
+                      <a16:colId xmlns:a16="http://schemas.microsoft.com/office/drawing/2014/main" val="466659687"/>
+                    </a:ext>
+                  </a:extLst>
+                </a:gridCol>
+                <a:gridCol w="2622507">
+                  <a:extLst>
+                    <a:ext uri="{9D8B030D-6E8A-4147-A177-3AD203B41FA5}">
+                      <a16:colId xmlns:a16="http://schemas.microsoft.com/office/drawing/2014/main" val="3110564245"/>
+                    </a:ext>
+                  </a:extLst>
+                </a:gridCol>
+                <a:gridCol w="1268295">
+                  <a:extLst>
+                    <a:ext uri="{9D8B030D-6E8A-4147-A177-3AD203B41FA5}">
+                      <a16:colId xmlns:a16="http://schemas.microsoft.com/office/drawing/2014/main" val="2588622405"/>
+                    </a:ext>
+                  </a:extLst>
+                </a:gridCol>
+                <a:gridCol w="2795705">
+                  <a:extLst>
+                    <a:ext uri="{9D8B030D-6E8A-4147-A177-3AD203B41FA5}">
+                      <a16:colId xmlns:a16="http://schemas.microsoft.com/office/drawing/2014/main" val="3611031613"/>
+                    </a:ext>
+                  </a:extLst>
+                </a:gridCol>
+              </a:tblGrid>
+              <a:tr h="370840">
+                <a:tc>
+                  <a:txBody>
+                    <a:bodyPr/>
+                    <a:lstStyle/>
+                    <a:p>
+                      <a:pPr algn="ctr" latinLnBrk="1"/>
+                      <a:r>
+                        <a:rPr lang="ko-KR" altLang="en-US" sz="1500" b="1" dirty="0"/>
+                        <a:t>이름</a:t>
+                      </a:r>
+                    </a:p>
+                  </a:txBody>
+                  <a:tcPr anchor="ctr">
+                    <a:solidFill>
+                      <a:schemeClr val="bg1">
+                        <a:lumMod val="85000"/>
+                      </a:schemeClr>
+                    </a:solidFill>
+                  </a:tcPr>
+                </a:tc>
+                <a:tc>
+                  <a:txBody>
+                    <a:bodyPr/>
+                    <a:lstStyle/>
+                    <a:p>
+                      <a:pPr latinLnBrk="1"/>
+                      <a:r>
+                        <a:rPr lang="ko-KR" altLang="en-US" sz="1500" b="0" dirty="0" err="1"/>
+                        <a:t>차한해</a:t>
+                      </a:r>
+                      <a:endParaRPr lang="ko-KR" altLang="en-US" sz="1500" b="0" dirty="0"/>
+                    </a:p>
+                  </a:txBody>
+                  <a:tcPr>
+                    <a:noFill/>
+                  </a:tcPr>
+                </a:tc>
+                <a:tc>
+                  <a:txBody>
+                    <a:bodyPr/>
+                    <a:lstStyle/>
+                    <a:p>
+                      <a:pPr algn="ctr" latinLnBrk="1"/>
+                      <a:r>
+                        <a:rPr lang="ko-KR" altLang="en-US" sz="1500" dirty="0"/>
+                        <a:t>역할</a:t>
+                      </a:r>
+                    </a:p>
+                  </a:txBody>
+                  <a:tcPr anchor="ctr">
+                    <a:solidFill>
+                      <a:schemeClr val="bg1">
+                        <a:lumMod val="85000"/>
+                      </a:schemeClr>
+                    </a:solidFill>
+                  </a:tcPr>
+                </a:tc>
+                <a:tc>
+                  <a:txBody>
+                    <a:bodyPr/>
+                    <a:lstStyle/>
+                    <a:p>
+                      <a:pPr latinLnBrk="1"/>
+                      <a:r>
+                        <a:rPr lang="ko-KR" altLang="en-US" sz="1500" b="0"/>
+                        <a:t>선의의 강제 희생자</a:t>
+                      </a:r>
+                      <a:endParaRPr lang="ko-KR" altLang="en-US" sz="1500" dirty="0"/>
+                    </a:p>
+                  </a:txBody>
+                  <a:tcPr>
+                    <a:noFill/>
+                  </a:tcPr>
+                </a:tc>
+                <a:extLst>
+                  <a:ext uri="{0D108BD9-81ED-4DB2-BD59-A6C34878D82A}">
+                    <a16:rowId xmlns:a16="http://schemas.microsoft.com/office/drawing/2014/main" val="3253351884"/>
+                  </a:ext>
+                </a:extLst>
+              </a:tr>
+              <a:tr h="370840">
+                <a:tc>
+                  <a:txBody>
+                    <a:bodyPr/>
+                    <a:lstStyle/>
+                    <a:p>
+                      <a:pPr algn="ctr" latinLnBrk="1"/>
+                      <a:r>
+                        <a:rPr lang="ko-KR" altLang="en-US" sz="1500" b="1" dirty="0"/>
+                        <a:t>선의 지수</a:t>
+                      </a:r>
+                    </a:p>
+                  </a:txBody>
+                  <a:tcPr anchor="ctr">
+                    <a:solidFill>
+                      <a:schemeClr val="bg1">
+                        <a:lumMod val="85000"/>
+                      </a:schemeClr>
+                    </a:solidFill>
+                  </a:tcPr>
+                </a:tc>
+                <a:tc>
+                  <a:txBody>
+                    <a:bodyPr/>
+                    <a:lstStyle/>
+                    <a:p>
+                      <a:pPr latinLnBrk="1"/>
+                      <a:r>
+                        <a:rPr lang="ko-KR" altLang="en-US" sz="1500" dirty="0"/>
+                        <a:t>∞</a:t>
+                      </a:r>
+                      <a:r>
+                        <a:rPr lang="en-US" altLang="ko-KR" sz="1500" dirty="0"/>
+                        <a:t>(</a:t>
+                      </a:r>
+                      <a:r>
+                        <a:rPr lang="ko-KR" altLang="en-US" sz="1500" dirty="0"/>
+                        <a:t>무한대</a:t>
+                      </a:r>
+                      <a:r>
+                        <a:rPr lang="en-US" altLang="ko-KR" sz="1500" dirty="0"/>
+                        <a:t>)</a:t>
+                      </a:r>
+                      <a:endParaRPr lang="ko-KR" altLang="en-US" sz="1500" dirty="0"/>
+                    </a:p>
+                  </a:txBody>
+                  <a:tcPr>
+                    <a:noFill/>
+                  </a:tcPr>
+                </a:tc>
+                <a:tc>
+                  <a:txBody>
+                    <a:bodyPr/>
+                    <a:lstStyle/>
+                    <a:p>
+                      <a:pPr algn="ctr" latinLnBrk="1"/>
+                      <a:r>
+                        <a:rPr lang="ko-KR" altLang="en-US" sz="1500" b="1" dirty="0"/>
+                        <a:t>특별 아이템</a:t>
+                      </a:r>
+                    </a:p>
+                  </a:txBody>
+                  <a:tcPr anchor="ctr">
+                    <a:solidFill>
+                      <a:schemeClr val="bg1">
+                        <a:lumMod val="85000"/>
+                      </a:schemeClr>
+                    </a:solidFill>
+                  </a:tcPr>
+                </a:tc>
+                <a:tc>
+                  <a:txBody>
+                    <a:bodyPr/>
+                    <a:lstStyle/>
+                    <a:p>
+                      <a:pPr latinLnBrk="1"/>
+                      <a:r>
+                        <a:rPr lang="ko-KR" altLang="en-US" sz="1500" dirty="0"/>
+                        <a:t>우정의 증표</a:t>
+                      </a:r>
+                      <a:endParaRPr lang="ko-KR" altLang="en-US" sz="1500" b="1" dirty="0"/>
+                    </a:p>
+                  </a:txBody>
+                  <a:tcPr>
+                    <a:noFill/>
+                  </a:tcPr>
+                </a:tc>
+                <a:extLst>
+                  <a:ext uri="{0D108BD9-81ED-4DB2-BD59-A6C34878D82A}">
+                    <a16:rowId xmlns:a16="http://schemas.microsoft.com/office/drawing/2014/main" val="708880270"/>
+                  </a:ext>
+                </a:extLst>
+              </a:tr>
+              <a:tr h="370840">
+                <a:tc>
+                  <a:txBody>
+                    <a:bodyPr/>
+                    <a:lstStyle/>
+                    <a:p>
+                      <a:pPr algn="ctr" latinLnBrk="1"/>
+                      <a:r>
+                        <a:rPr lang="ko-KR" altLang="en-US" sz="1500" b="1" dirty="0"/>
+                        <a:t>배경 요약</a:t>
+                      </a:r>
+                    </a:p>
+                  </a:txBody>
+                  <a:tcPr anchor="ctr">
+                    <a:solidFill>
+                      <a:schemeClr val="bg1">
+                        <a:lumMod val="85000"/>
+                      </a:schemeClr>
+                    </a:solidFill>
+                  </a:tcPr>
+                </a:tc>
+                <a:tc gridSpan="3">
+                  <a:txBody>
+                    <a:bodyPr/>
+                    <a:lstStyle/>
+                    <a:p>
+                      <a:pPr latinLnBrk="1"/>
+                      <a:r>
+                        <a:rPr lang="ko-KR" altLang="en-US" sz="1500" dirty="0"/>
+                        <a:t>입양아</a:t>
+                      </a:r>
+                      <a:r>
+                        <a:rPr lang="en-US" altLang="ko-KR" sz="1500" dirty="0"/>
+                        <a:t>. </a:t>
+                      </a:r>
+                      <a:r>
+                        <a:rPr lang="ko-KR" altLang="en-US" sz="1500" dirty="0"/>
+                        <a:t>동생을 위한 희생 강요 환경에서 성장</a:t>
+                      </a:r>
+                      <a:r>
+                        <a:rPr lang="en-US" altLang="ko-KR" sz="1500" dirty="0"/>
+                        <a:t>. </a:t>
+                      </a:r>
+                      <a:r>
+                        <a:rPr lang="ko-KR" altLang="en-US" sz="1500" dirty="0" err="1"/>
+                        <a:t>붑모</a:t>
+                      </a:r>
+                      <a:r>
+                        <a:rPr lang="ko-KR" altLang="en-US" sz="1500" dirty="0"/>
+                        <a:t> 기대 부응 위해 </a:t>
+                      </a:r>
+                      <a:r>
+                        <a:rPr lang="en-US" altLang="ko-KR" sz="1500" dirty="0"/>
+                        <a:t>‘</a:t>
+                      </a:r>
+                      <a:r>
+                        <a:rPr lang="ko-KR" altLang="en-US" sz="1500" dirty="0"/>
+                        <a:t>착한 아이 증후군</a:t>
+                      </a:r>
+                      <a:r>
+                        <a:rPr lang="en-US" altLang="ko-KR" sz="1500" dirty="0"/>
+                        <a:t>’ </a:t>
+                      </a:r>
+                      <a:r>
+                        <a:rPr lang="ko-KR" altLang="en-US" sz="1500" dirty="0"/>
+                        <a:t>및 </a:t>
+                      </a:r>
+                      <a:r>
+                        <a:rPr lang="en-US" altLang="ko-KR" sz="1500" dirty="0"/>
+                        <a:t>‘</a:t>
+                      </a:r>
+                      <a:r>
+                        <a:rPr lang="ko-KR" altLang="en-US" sz="1500" dirty="0"/>
+                        <a:t>선행 강박</a:t>
+                      </a:r>
+                      <a:r>
+                        <a:rPr lang="en-US" altLang="ko-KR" sz="1500" dirty="0"/>
+                        <a:t>’ </a:t>
+                      </a:r>
+                      <a:r>
+                        <a:rPr lang="ko-KR" altLang="en-US" sz="1500" dirty="0"/>
+                        <a:t>형성</a:t>
+                      </a:r>
+                      <a:r>
+                        <a:rPr lang="en-US" altLang="ko-KR" sz="1500" dirty="0"/>
+                        <a:t>.</a:t>
+                      </a:r>
+                      <a:endParaRPr lang="ko-KR" altLang="en-US" sz="1500" dirty="0"/>
+                    </a:p>
+                  </a:txBody>
+                  <a:tcPr>
+                    <a:noFill/>
+                  </a:tcPr>
+                </a:tc>
+                <a:tc hMerge="1">
+                  <a:txBody>
+                    <a:bodyPr/>
+                    <a:lstStyle/>
+                    <a:p>
+                      <a:pPr latinLnBrk="1"/>
+                      <a:endParaRPr lang="ko-KR" altLang="en-US" sz="1500" dirty="0"/>
+                    </a:p>
+                  </a:txBody>
+                  <a:tcPr>
+                    <a:noFill/>
+                  </a:tcPr>
+                </a:tc>
+                <a:tc hMerge="1">
+                  <a:txBody>
+                    <a:bodyPr/>
+                    <a:lstStyle/>
+                    <a:p>
+                      <a:pPr latinLnBrk="1"/>
+                      <a:endParaRPr lang="ko-KR" altLang="en-US"/>
+                    </a:p>
+                  </a:txBody>
+                  <a:tcPr/>
+                </a:tc>
+                <a:extLst>
+                  <a:ext uri="{0D108BD9-81ED-4DB2-BD59-A6C34878D82A}">
+                    <a16:rowId xmlns:a16="http://schemas.microsoft.com/office/drawing/2014/main" val="3937360949"/>
+                  </a:ext>
+                </a:extLst>
+              </a:tr>
+              <a:tr h="370840">
+                <a:tc>
+                  <a:txBody>
+                    <a:bodyPr/>
+                    <a:lstStyle/>
+                    <a:p>
+                      <a:pPr algn="ctr" latinLnBrk="1"/>
+                      <a:r>
+                        <a:rPr lang="ko-KR" altLang="en-US" sz="1500" b="1" dirty="0"/>
+                        <a:t>성격</a:t>
+                      </a:r>
+                    </a:p>
+                  </a:txBody>
+                  <a:tcPr anchor="ctr">
+                    <a:solidFill>
+                      <a:schemeClr val="bg1">
+                        <a:lumMod val="85000"/>
+                      </a:schemeClr>
+                    </a:solidFill>
+                  </a:tcPr>
+                </a:tc>
+                <a:tc gridSpan="3">
+                  <a:txBody>
+                    <a:bodyPr/>
+                    <a:lstStyle/>
+                    <a:p>
+                      <a:pPr latinLnBrk="1"/>
+                      <a:r>
+                        <a:rPr lang="ko-KR" altLang="en-US" sz="1500" dirty="0"/>
+                        <a:t>온화하고 순응적</a:t>
+                      </a:r>
+                      <a:r>
+                        <a:rPr lang="en-US" altLang="ko-KR" sz="1500" dirty="0"/>
+                        <a:t>. </a:t>
+                      </a:r>
+                      <a:r>
+                        <a:rPr lang="ko-KR" altLang="en-US" sz="1500" dirty="0"/>
+                        <a:t>스스로 착하다고 생각하지 않으나</a:t>
+                      </a:r>
+                      <a:r>
+                        <a:rPr lang="en-US" altLang="ko-KR" sz="1500" dirty="0"/>
+                        <a:t>, </a:t>
+                      </a:r>
+                      <a:r>
+                        <a:rPr lang="ko-KR" altLang="en-US" sz="1500" dirty="0"/>
+                        <a:t>주변의 </a:t>
+                      </a:r>
+                      <a:r>
+                        <a:rPr lang="en-US" altLang="ko-KR" sz="1500" dirty="0"/>
+                        <a:t>‘</a:t>
+                      </a:r>
+                      <a:r>
+                        <a:rPr lang="ko-KR" altLang="en-US" sz="1500" dirty="0"/>
+                        <a:t>가장 착한 사람</a:t>
+                      </a:r>
+                      <a:r>
+                        <a:rPr lang="en-US" altLang="ko-KR" sz="1500" dirty="0"/>
+                        <a:t>’ </a:t>
+                      </a:r>
+                      <a:r>
+                        <a:rPr lang="ko-KR" altLang="en-US" sz="1500" dirty="0"/>
+                        <a:t>평가에 만족</a:t>
+                      </a:r>
+                      <a:r>
+                        <a:rPr lang="en-US" altLang="ko-KR" sz="1500" dirty="0"/>
+                        <a:t>. </a:t>
+                      </a:r>
+                      <a:r>
+                        <a:rPr lang="ko-KR" altLang="en-US" sz="1500" dirty="0"/>
+                        <a:t>인정 욕구 강함</a:t>
+                      </a:r>
+                      <a:r>
+                        <a:rPr lang="en-US" altLang="ko-KR" sz="1500" dirty="0"/>
+                        <a:t>.</a:t>
+                      </a:r>
+                      <a:endParaRPr lang="ko-KR" altLang="en-US" sz="1500" dirty="0"/>
+                    </a:p>
+                  </a:txBody>
+                  <a:tcPr>
+                    <a:noFill/>
+                  </a:tcPr>
+                </a:tc>
+                <a:tc hMerge="1">
+                  <a:txBody>
+                    <a:bodyPr/>
+                    <a:lstStyle/>
+                    <a:p>
+                      <a:pPr latinLnBrk="1"/>
+                      <a:endParaRPr lang="ko-KR" altLang="en-US" sz="1500" dirty="0"/>
+                    </a:p>
+                  </a:txBody>
+                  <a:tcPr>
+                    <a:noFill/>
+                  </a:tcPr>
+                </a:tc>
+                <a:tc hMerge="1">
+                  <a:txBody>
+                    <a:bodyPr/>
+                    <a:lstStyle/>
+                    <a:p>
+                      <a:pPr latinLnBrk="1"/>
+                      <a:endParaRPr lang="ko-KR" altLang="en-US"/>
+                    </a:p>
+                  </a:txBody>
+                  <a:tcPr/>
+                </a:tc>
+                <a:extLst>
+                  <a:ext uri="{0D108BD9-81ED-4DB2-BD59-A6C34878D82A}">
+                    <a16:rowId xmlns:a16="http://schemas.microsoft.com/office/drawing/2014/main" val="1247399955"/>
+                  </a:ext>
+                </a:extLst>
+              </a:tr>
+              <a:tr h="370840">
+                <a:tc>
+                  <a:txBody>
+                    <a:bodyPr/>
+                    <a:lstStyle/>
+                    <a:p>
+                      <a:pPr algn="ctr" latinLnBrk="1"/>
+                      <a:r>
+                        <a:rPr lang="ko-KR" altLang="en-US" sz="1500" b="1" dirty="0"/>
+                        <a:t>능력</a:t>
+                      </a:r>
+                    </a:p>
+                  </a:txBody>
+                  <a:tcPr anchor="ctr">
+                    <a:solidFill>
+                      <a:schemeClr val="bg1">
+                        <a:lumMod val="85000"/>
+                      </a:schemeClr>
+                    </a:solidFill>
+                  </a:tcPr>
+                </a:tc>
+                <a:tc>
+                  <a:txBody>
+                    <a:bodyPr/>
+                    <a:lstStyle/>
+                    <a:p>
+                      <a:pPr marL="285750" indent="-285750" latinLnBrk="1">
+                        <a:buFont typeface="Arial" panose="020B0604020202020204" pitchFamily="34" charset="0"/>
+                        <a:buChar char="•"/>
+                      </a:pPr>
+                      <a:r>
+                        <a:rPr lang="ko-KR" altLang="en-US" sz="1500" dirty="0"/>
+                        <a:t>선의 타격</a:t>
+                      </a:r>
+                      <a:endParaRPr lang="en-US" altLang="ko-KR" sz="1500" dirty="0"/>
+                    </a:p>
+                    <a:p>
+                      <a:pPr marL="285750" indent="-285750" latinLnBrk="1">
+                        <a:buFont typeface="Arial" panose="020B0604020202020204" pitchFamily="34" charset="0"/>
+                        <a:buChar char="•"/>
+                      </a:pPr>
+                      <a:r>
+                        <a:rPr lang="ko-KR" altLang="en-US" sz="1500" dirty="0"/>
+                        <a:t>공감 </a:t>
+                      </a:r>
+                      <a:r>
+                        <a:rPr lang="en-US" altLang="ko-KR" sz="1500" dirty="0"/>
+                        <a:t>(</a:t>
+                      </a:r>
+                      <a:r>
+                        <a:rPr lang="ko-KR" altLang="en-US" sz="1500" dirty="0"/>
+                        <a:t>버프</a:t>
+                      </a:r>
+                      <a:r>
+                        <a:rPr lang="en-US" altLang="ko-KR" sz="1500" dirty="0"/>
+                        <a:t>)</a:t>
+                      </a:r>
+                    </a:p>
+                    <a:p>
+                      <a:pPr marL="285750" indent="-285750" latinLnBrk="1">
+                        <a:buFont typeface="Arial" panose="020B0604020202020204" pitchFamily="34" charset="0"/>
+                        <a:buChar char="•"/>
+                      </a:pPr>
+                      <a:r>
+                        <a:rPr lang="ko-KR" altLang="en-US" sz="1500" dirty="0"/>
+                        <a:t>몰입 </a:t>
+                      </a:r>
+                      <a:r>
+                        <a:rPr lang="en-US" altLang="ko-KR" sz="1500" dirty="0"/>
+                        <a:t>(</a:t>
+                      </a:r>
+                      <a:r>
+                        <a:rPr lang="ko-KR" altLang="en-US" sz="1500" dirty="0"/>
+                        <a:t>강화</a:t>
+                      </a:r>
+                      <a:r>
+                        <a:rPr lang="en-US" altLang="ko-KR" sz="1500" dirty="0"/>
+                        <a:t>)</a:t>
+                      </a:r>
+                      <a:endParaRPr lang="ko-KR" altLang="en-US" sz="1500" dirty="0"/>
+                    </a:p>
+                  </a:txBody>
+                  <a:tcPr>
+                    <a:noFill/>
+                  </a:tcPr>
+                </a:tc>
+                <a:tc>
+                  <a:txBody>
+                    <a:bodyPr/>
+                    <a:lstStyle/>
+                    <a:p>
+                      <a:pPr algn="ctr" latinLnBrk="1"/>
+                      <a:r>
+                        <a:rPr lang="ko-KR" altLang="en-US" sz="1500" b="1" dirty="0"/>
+                        <a:t>약점</a:t>
+                      </a:r>
+                    </a:p>
+                  </a:txBody>
+                  <a:tcPr anchor="ctr">
+                    <a:solidFill>
+                      <a:schemeClr val="bg1">
+                        <a:lumMod val="85000"/>
+                      </a:schemeClr>
+                    </a:solidFill>
+                  </a:tcPr>
+                </a:tc>
+                <a:tc>
+                  <a:txBody>
+                    <a:bodyPr/>
+                    <a:lstStyle/>
+                    <a:p>
+                      <a:pPr marL="285750" indent="-285750" latinLnBrk="1">
+                        <a:buFont typeface="Arial" panose="020B0604020202020204" pitchFamily="34" charset="0"/>
+                        <a:buChar char="•"/>
+                      </a:pPr>
+                      <a:r>
+                        <a:rPr lang="ko-KR" altLang="en-US" sz="1500" dirty="0"/>
+                        <a:t>희생 강요 </a:t>
+                      </a:r>
+                      <a:r>
+                        <a:rPr lang="en-US" altLang="ko-KR" sz="1500" dirty="0"/>
+                        <a:t>(</a:t>
+                      </a:r>
+                      <a:r>
+                        <a:rPr lang="ko-KR" altLang="en-US" sz="1500" dirty="0" err="1"/>
+                        <a:t>디버프</a:t>
+                      </a:r>
+                      <a:r>
+                        <a:rPr lang="en-US" altLang="ko-KR" sz="1500" dirty="0"/>
+                        <a:t>)</a:t>
+                      </a:r>
+                    </a:p>
+                    <a:p>
+                      <a:pPr marL="285750" indent="-285750" latinLnBrk="1">
+                        <a:buFont typeface="Arial" panose="020B0604020202020204" pitchFamily="34" charset="0"/>
+                        <a:buChar char="•"/>
+                      </a:pPr>
+                      <a:r>
+                        <a:rPr lang="ko-KR" altLang="en-US" sz="1500" dirty="0"/>
+                        <a:t>선행 거절 </a:t>
+                      </a:r>
+                      <a:r>
+                        <a:rPr lang="en-US" altLang="ko-KR" sz="1500" dirty="0"/>
+                        <a:t>(</a:t>
+                      </a:r>
+                      <a:r>
+                        <a:rPr lang="ko-KR" altLang="en-US" sz="1500" dirty="0"/>
+                        <a:t>이속 제한</a:t>
+                      </a:r>
+                      <a:r>
+                        <a:rPr lang="en-US" altLang="ko-KR" sz="1500" dirty="0"/>
+                        <a:t>)</a:t>
+                      </a:r>
+                      <a:endParaRPr lang="ko-KR" altLang="en-US" sz="1500" b="1" dirty="0"/>
+                    </a:p>
+                  </a:txBody>
+                  <a:tcPr>
+                    <a:noFill/>
+                  </a:tcPr>
+                </a:tc>
+                <a:extLst>
+                  <a:ext uri="{0D108BD9-81ED-4DB2-BD59-A6C34878D82A}">
+                    <a16:rowId xmlns:a16="http://schemas.microsoft.com/office/drawing/2014/main" val="2191310370"/>
+                  </a:ext>
+                </a:extLst>
+              </a:tr>
+              <a:tr h="370840">
+                <a:tc>
+                  <a:txBody>
+                    <a:bodyPr/>
+                    <a:lstStyle/>
+                    <a:p>
+                      <a:pPr algn="ctr" latinLnBrk="1"/>
+                      <a:r>
+                        <a:rPr lang="ko-KR" altLang="en-US" sz="1500" b="1" dirty="0"/>
+                        <a:t>게임 내 역할</a:t>
+                      </a:r>
+                    </a:p>
+                  </a:txBody>
+                  <a:tcPr anchor="ctr">
+                    <a:solidFill>
+                      <a:schemeClr val="bg1">
+                        <a:lumMod val="85000"/>
+                      </a:schemeClr>
+                    </a:solidFill>
+                  </a:tcPr>
+                </a:tc>
+                <a:tc gridSpan="3">
+                  <a:txBody>
+                    <a:bodyPr/>
+                    <a:lstStyle/>
+                    <a:p>
+                      <a:pPr latinLnBrk="1"/>
+                      <a:r>
+                        <a:rPr lang="ko-KR" altLang="en-US" sz="1500" dirty="0"/>
+                        <a:t>착함 테마의 핵심 갈등 담당</a:t>
+                      </a:r>
+                      <a:r>
+                        <a:rPr lang="en-US" altLang="ko-KR" sz="1500" dirty="0"/>
+                        <a:t>. </a:t>
+                      </a:r>
+                      <a:r>
+                        <a:rPr lang="ko-KR" altLang="en-US" sz="1500" dirty="0"/>
+                        <a:t>자발적 영웅 ↔ 강제 희생양 분기</a:t>
+                      </a:r>
+                    </a:p>
+                  </a:txBody>
+                  <a:tcPr>
+                    <a:noFill/>
+                  </a:tcPr>
+                </a:tc>
+                <a:tc hMerge="1">
+                  <a:txBody>
+                    <a:bodyPr/>
+                    <a:lstStyle/>
+                    <a:p>
+                      <a:pPr latinLnBrk="1"/>
+                      <a:endParaRPr lang="ko-KR" altLang="en-US" sz="1500" dirty="0"/>
+                    </a:p>
+                  </a:txBody>
+                  <a:tcPr>
+                    <a:noFill/>
+                  </a:tcPr>
+                </a:tc>
+                <a:tc hMerge="1">
+                  <a:txBody>
+                    <a:bodyPr/>
+                    <a:lstStyle/>
+                    <a:p>
+                      <a:pPr latinLnBrk="1"/>
+                      <a:endParaRPr lang="ko-KR" altLang="en-US"/>
+                    </a:p>
+                  </a:txBody>
+                  <a:tcPr/>
+                </a:tc>
+                <a:extLst>
+                  <a:ext uri="{0D108BD9-81ED-4DB2-BD59-A6C34878D82A}">
+                    <a16:rowId xmlns:a16="http://schemas.microsoft.com/office/drawing/2014/main" val="3383075920"/>
+                  </a:ext>
+                </a:extLst>
+              </a:tr>
+              <a:tr h="3074583">
+                <a:tc>
+                  <a:txBody>
+                    <a:bodyPr/>
+                    <a:lstStyle/>
+                    <a:p>
+                      <a:pPr algn="ctr" latinLnBrk="1"/>
+                      <a:r>
+                        <a:rPr lang="en-US" altLang="ko-KR" sz="1500" b="1" dirty="0"/>
+                        <a:t>2D</a:t>
+                      </a:r>
+                      <a:endParaRPr lang="ko-KR" altLang="en-US" sz="1500" b="1" dirty="0"/>
+                    </a:p>
+                  </a:txBody>
+                  <a:tcPr anchor="ctr">
+                    <a:solidFill>
+                      <a:schemeClr val="bg1">
+                        <a:lumMod val="85000"/>
+                      </a:schemeClr>
+                    </a:solidFill>
+                  </a:tcPr>
+                </a:tc>
+                <a:tc>
+                  <a:txBody>
+                    <a:bodyPr/>
+                    <a:lstStyle/>
+                    <a:p>
+                      <a:pPr latinLnBrk="1"/>
+                      <a:endParaRPr lang="ko-KR" altLang="en-US" sz="1500" dirty="0"/>
+                    </a:p>
+                  </a:txBody>
+                  <a:tcPr>
+                    <a:noFill/>
+                  </a:tcPr>
+                </a:tc>
+                <a:tc>
+                  <a:txBody>
+                    <a:bodyPr/>
+                    <a:lstStyle/>
+                    <a:p>
+                      <a:pPr algn="ctr" latinLnBrk="1"/>
+                      <a:r>
+                        <a:rPr lang="ko-KR" altLang="en-US" sz="1500" b="1" dirty="0"/>
+                        <a:t>도트</a:t>
+                      </a:r>
+                    </a:p>
+                  </a:txBody>
+                  <a:tcPr anchor="ctr">
+                    <a:solidFill>
+                      <a:schemeClr val="bg1">
+                        <a:lumMod val="85000"/>
+                      </a:schemeClr>
+                    </a:solidFill>
+                  </a:tcPr>
+                </a:tc>
+                <a:tc>
+                  <a:txBody>
+                    <a:bodyPr/>
+                    <a:lstStyle/>
+                    <a:p>
+                      <a:pPr latinLnBrk="1"/>
+                      <a:endParaRPr lang="ko-KR" altLang="en-US" sz="1500" b="1" dirty="0"/>
+                    </a:p>
+                  </a:txBody>
+                  <a:tcPr>
+                    <a:noFill/>
+                  </a:tcPr>
+                </a:tc>
+                <a:extLst>
+                  <a:ext uri="{0D108BD9-81ED-4DB2-BD59-A6C34878D82A}">
+                    <a16:rowId xmlns:a16="http://schemas.microsoft.com/office/drawing/2014/main" val="3480288161"/>
+                  </a:ext>
+                </a:extLst>
+              </a:tr>
+            </a:tbl>
+          </a:graphicData>
+        </a:graphic>
+      </p:graphicFrame>
+      <p:pic>
+        <p:nvPicPr>
+          <p:cNvPr id="8" name="그림 7">
+            <a:extLst>
+              <a:ext uri="{FF2B5EF4-FFF2-40B4-BE49-F238E27FC236}">
+                <a16:creationId xmlns:a16="http://schemas.microsoft.com/office/drawing/2014/main" id="{19B34CCB-9FB9-9A22-0438-0FF6DC3FDBAE}"/>
+              </a:ext>
+            </a:extLst>
+          </p:cNvPr>
+          <p:cNvPicPr>
+            <a:picLocks noChangeAspect="1"/>
+          </p:cNvPicPr>
+          <p:nvPr/>
+        </p:nvPicPr>
+        <p:blipFill>
+          <a:blip r:embed="rId2">
+            <a:extLst>
+              <a:ext uri="{BEBA8EAE-BF5A-486C-A8C5-ECC9F3942E4B}">
+                <a14:imgProps xmlns:a14="http://schemas.microsoft.com/office/drawing/2010/main">
+                  <a14:imgLayer r:embed="rId3">
+                    <a14:imgEffect>
+                      <a14:backgroundRemoval t="0" b="100000" l="0" r="100000">
+                        <a14:foregroundMark x1="20504" y1="52295" x2="21223" y2="53408"/>
+                        <a14:foregroundMark x1="88849" y1="51321" x2="86691" y2="54381"/>
+                        <a14:foregroundMark x1="23022" y1="51739" x2="23741" y2="53686"/>
+                        <a14:foregroundMark x1="44964" y1="76773" x2="50000" y2="96523"/>
+                        <a14:foregroundMark x1="63309" y1="80807" x2="66187" y2="96384"/>
+                        <a14:foregroundMark x1="10791" y1="35049" x2="6115" y2="40195"/>
+                        <a14:foregroundMark x1="8273" y1="43394" x2="10072" y2="45480"/>
+                        <a14:foregroundMark x1="42806" y1="87622" x2="41367" y2="90125"/>
+                        <a14:foregroundMark x1="58273" y1="84006" x2="57554" y2="86648"/>
+                        <a14:backgroundMark x1="54317" y1="55355" x2="52878" y2="81502"/>
+                        <a14:backgroundMark x1="23741" y1="27816" x2="23741" y2="27816"/>
+                        <a14:backgroundMark x1="23381" y1="28512" x2="23381" y2="28512"/>
+                        <a14:backgroundMark x1="61151" y1="15021" x2="61151" y2="15021"/>
+                        <a14:backgroundMark x1="58993" y1="14882" x2="58993" y2="14882"/>
+                      </a14:backgroundRemoval>
+                    </a14:imgEffect>
+                  </a14:imgLayer>
+                </a14:imgProps>
+              </a:ext>
+            </a:extLst>
+          </a:blip>
+          <a:stretch>
+            <a:fillRect/>
+          </a:stretch>
+        </p:blipFill>
+        <p:spPr>
+          <a:xfrm>
+            <a:off x="4270177" y="3529084"/>
+            <a:ext cx="1078905" cy="2790405"/>
+          </a:xfrm>
+          <a:prstGeom prst="rect">
+            <a:avLst/>
+          </a:prstGeom>
+        </p:spPr>
+      </p:pic>
+      <p:pic>
+        <p:nvPicPr>
+          <p:cNvPr id="9" name="그림 8">
+            <a:extLst>
+              <a:ext uri="{FF2B5EF4-FFF2-40B4-BE49-F238E27FC236}">
+                <a16:creationId xmlns:a16="http://schemas.microsoft.com/office/drawing/2014/main" id="{7629C32B-1AFA-68C8-8F4E-2D1E7E139F5D}"/>
+              </a:ext>
+            </a:extLst>
+          </p:cNvPr>
+          <p:cNvPicPr>
+            <a:picLocks noChangeAspect="1"/>
+          </p:cNvPicPr>
+          <p:nvPr/>
+        </p:nvPicPr>
+        <p:blipFill>
+          <a:blip r:embed="rId4">
+            <a:extLst>
+              <a:ext uri="{BEBA8EAE-BF5A-486C-A8C5-ECC9F3942E4B}">
+                <a14:imgProps xmlns:a14="http://schemas.microsoft.com/office/drawing/2010/main">
+                  <a14:imgLayer r:embed="rId5">
+                    <a14:imgEffect>
+                      <a14:backgroundRemoval t="0" b="100000" l="0" r="100000">
+                        <a14:backgroundMark x1="10345" y1="4310" x2="10345" y2="4310"/>
+                        <a14:backgroundMark x1="17241" y1="6034" x2="1724" y2="36207"/>
+                        <a14:backgroundMark x1="81034" y1="3448" x2="94828" y2="22414"/>
+                        <a14:backgroundMark x1="15517" y1="3448" x2="81034" y2="862"/>
+                        <a14:backgroundMark x1="94828" y1="23276" x2="91379" y2="49138"/>
+                        <a14:backgroundMark x1="93103" y1="49138" x2="94828" y2="77586"/>
+                        <a14:backgroundMark x1="1724" y1="34483" x2="6897" y2="50862"/>
+                        <a14:backgroundMark x1="6897" y1="51724" x2="1724" y2="74138"/>
+                        <a14:backgroundMark x1="5172" y1="73276" x2="17241" y2="95690"/>
+                        <a14:backgroundMark x1="93103" y1="76724" x2="81034" y2="94828"/>
+                      </a14:backgroundRemoval>
+                    </a14:imgEffect>
+                  </a14:imgLayer>
+                </a14:imgProps>
+              </a:ext>
+            </a:extLst>
+          </a:blip>
+          <a:stretch>
+            <a:fillRect/>
+          </a:stretch>
+        </p:blipFill>
+        <p:spPr>
+          <a:xfrm>
+            <a:off x="8310223" y="3974578"/>
+            <a:ext cx="949708" cy="1899416"/>
+          </a:xfrm>
+          <a:prstGeom prst="rect">
+            <a:avLst/>
+          </a:prstGeom>
+        </p:spPr>
+      </p:pic>
+    </p:spTree>
+    <p:extLst>
+      <p:ext uri="{BB962C8B-B14F-4D97-AF65-F5344CB8AC3E}">
+        <p14:creationId xmlns:p14="http://schemas.microsoft.com/office/powerpoint/2010/main" val="1648487806"/>
+      </p:ext>
+    </p:extLst>
+  </p:cSld>
+  <p:clrMapOvr>
+    <a:masterClrMapping/>
+  </p:clrMapOvr>
+</p:sld>
+</file>
+
+<file path=ppt/slides/slide2.xml><?xml version="1.0" encoding="utf-8"?>
+<p:sld xmlns:a="http://schemas.openxmlformats.org/drawingml/2006/main" xmlns:r="http://schemas.openxmlformats.org/officeDocument/2006/relationships" xmlns:p="http://schemas.openxmlformats.org/presentationml/2006/main">
+  <p:cSld>
+    <p:spTree>
+      <p:nvGrpSpPr>
+        <p:cNvPr id="1" name=""/>
+        <p:cNvGrpSpPr/>
+        <p:nvPr/>
+      </p:nvGrpSpPr>
+      <p:grpSpPr>
+        <a:xfrm>
+          <a:off x="0" y="0"/>
+          <a:ext cx="0" cy="0"/>
+          <a:chOff x="0" y="0"/>
+          <a:chExt cx="0" cy="0"/>
+        </a:xfrm>
+      </p:grpSpPr>
+      <p:sp>
+        <p:nvSpPr>
+          <p:cNvPr id="2" name="제목 1"/>
+          <p:cNvSpPr>
+            <a:spLocks noGrp="1"/>
+          </p:cNvSpPr>
+          <p:nvPr>
+            <p:ph type="title"/>
+          </p:nvPr>
+        </p:nvSpPr>
+        <p:spPr/>
+        <p:txBody>
+          <a:bodyPr>
+            <a:normAutofit/>
+          </a:bodyPr>
+          <a:lstStyle/>
+          <a:p>
+            <a:r>
+              <a:rPr lang="ko-KR" altLang="en-US" sz="4000"/>
+              <a:t>우리는 없는 존재에게 설정값을 넣어야 한다</a:t>
+            </a:r>
+            <a:r>
+              <a:rPr lang="en-US" altLang="ko-KR" sz="4000"/>
+              <a:t>.</a:t>
+            </a:r>
+            <a:endParaRPr lang="ko-KR" altLang="en-US" sz="4000"/>
+          </a:p>
+        </p:txBody>
+      </p:sp>
+      <p:sp>
+        <p:nvSpPr>
+          <p:cNvPr id="3" name="내용 개체 틀 2"/>
+          <p:cNvSpPr>
+            <a:spLocks noGrp="1"/>
+          </p:cNvSpPr>
+          <p:nvPr>
+            <p:ph idx="1"/>
+          </p:nvPr>
+        </p:nvSpPr>
+        <p:spPr/>
+        <p:txBody>
+          <a:bodyPr/>
+          <a:lstStyle/>
+          <a:p>
+            <a:r>
+              <a:rPr lang="ko-KR" altLang="en-US"/>
+              <a:t>설정값 </a:t>
+            </a:r>
+            <a:r>
+              <a:rPr lang="en-US" altLang="ko-KR"/>
+              <a:t>=&gt; </a:t>
+            </a:r>
+            <a:r>
+              <a:rPr lang="ko-KR" altLang="en-US" b="1"/>
+              <a:t>게임에 필요한 것</a:t>
+            </a:r>
+            <a:r>
+              <a:rPr lang="ko-KR" altLang="en-US"/>
+              <a:t>이어야 한다</a:t>
+            </a:r>
+            <a:r>
+              <a:rPr lang="en-US" altLang="ko-KR"/>
+              <a:t>.</a:t>
+            </a:r>
+          </a:p>
+          <a:p>
+            <a:endParaRPr lang="en-US" altLang="ko-KR"/>
+          </a:p>
+          <a:p>
+            <a:r>
+              <a:rPr lang="ko-KR" altLang="en-US"/>
+              <a:t>필요하지 않은 설정 인자는 넣을 필요 없다</a:t>
+            </a:r>
+            <a:r>
+              <a:rPr lang="en-US" altLang="ko-KR"/>
+              <a:t>!</a:t>
+            </a:r>
+            <a:br>
+              <a:rPr lang="en-US" altLang="ko-KR"/>
+            </a:br>
+            <a:r>
+              <a:rPr lang="ko-KR" altLang="en-US"/>
+              <a:t>예</a:t>
+            </a:r>
+            <a:r>
+              <a:rPr lang="en-US" altLang="ko-KR"/>
+              <a:t>) </a:t>
+            </a:r>
+            <a:r>
+              <a:rPr lang="ko-KR" altLang="en-US"/>
+              <a:t>혈액형</a:t>
+            </a:r>
+          </a:p>
+        </p:txBody>
+      </p:sp>
+    </p:spTree>
+    <p:extLst>
+      <p:ext uri="{BB962C8B-B14F-4D97-AF65-F5344CB8AC3E}">
+        <p14:creationId xmlns:p14="http://schemas.microsoft.com/office/powerpoint/2010/main" val="2052281943"/>
+      </p:ext>
+    </p:extLst>
+  </p:cSld>
+  <p:clrMapOvr>
+    <a:masterClrMapping/>
+  </p:clrMapOvr>
+</p:sld>
+</file>
+
+<file path=ppt/slides/slide3.xml><?xml version="1.0" encoding="utf-8"?>
+<p:sld xmlns:a="http://schemas.openxmlformats.org/drawingml/2006/main" xmlns:r="http://schemas.openxmlformats.org/officeDocument/2006/relationships" xmlns:p="http://schemas.openxmlformats.org/presentationml/2006/main">
+  <p:cSld>
+    <p:spTree>
+      <p:nvGrpSpPr>
+        <p:cNvPr id="1" name=""/>
+        <p:cNvGrpSpPr/>
+        <p:nvPr/>
+      </p:nvGrpSpPr>
+      <p:grpSpPr>
+        <a:xfrm>
+          <a:off x="0" y="0"/>
+          <a:ext cx="0" cy="0"/>
+          <a:chOff x="0" y="0"/>
+          <a:chExt cx="0" cy="0"/>
+        </a:xfrm>
+      </p:grpSpPr>
+      <p:sp>
+        <p:nvSpPr>
+          <p:cNvPr id="2" name="제목 1"/>
+          <p:cNvSpPr>
+            <a:spLocks noGrp="1"/>
+          </p:cNvSpPr>
+          <p:nvPr>
+            <p:ph type="title"/>
+          </p:nvPr>
+        </p:nvSpPr>
+        <p:spPr/>
+        <p:txBody>
+          <a:bodyPr/>
+          <a:lstStyle/>
+          <a:p>
+            <a:r>
+              <a:rPr lang="ko-KR" altLang="en-US"/>
+              <a:t>해야할 것</a:t>
+            </a:r>
+          </a:p>
+        </p:txBody>
+      </p:sp>
+      <p:sp>
+        <p:nvSpPr>
+          <p:cNvPr id="3" name="내용 개체 틀 2"/>
+          <p:cNvSpPr>
+            <a:spLocks noGrp="1"/>
+          </p:cNvSpPr>
+          <p:nvPr>
+            <p:ph idx="1"/>
+          </p:nvPr>
+        </p:nvSpPr>
+        <p:spPr>
+          <a:xfrm>
+            <a:off x="637309" y="1825625"/>
+            <a:ext cx="10917382" cy="4351338"/>
+          </a:xfrm>
+        </p:spPr>
+        <p:txBody>
+          <a:bodyPr/>
+          <a:lstStyle/>
+          <a:p>
+            <a:r>
+              <a:rPr lang="ko-KR" altLang="en-US"/>
+              <a:t>캐릭터의 전신 이미지</a:t>
+            </a:r>
+            <a:endParaRPr lang="en-US" altLang="ko-KR"/>
+          </a:p>
+          <a:p>
+            <a:r>
+              <a:rPr lang="ko-KR" altLang="en-US"/>
+              <a:t>화살표 선과 글상자로 설정값들을 넣어보자</a:t>
+            </a:r>
+            <a:r>
+              <a:rPr lang="en-US" altLang="ko-KR"/>
+              <a:t>.</a:t>
+            </a:r>
+          </a:p>
+          <a:p>
+            <a:r>
+              <a:rPr lang="ko-KR" altLang="en-US"/>
+              <a:t>외형이 아니더라도</a:t>
+            </a:r>
+            <a:r>
+              <a:rPr lang="en-US" altLang="ko-KR"/>
+              <a:t>, </a:t>
+            </a:r>
+            <a:r>
+              <a:rPr lang="ko-KR" altLang="en-US"/>
+              <a:t>그 사람이 가지고 있는 것들에 대해 적어보자</a:t>
+            </a:r>
+          </a:p>
+        </p:txBody>
+      </p:sp>
+    </p:spTree>
+    <p:extLst>
+      <p:ext uri="{BB962C8B-B14F-4D97-AF65-F5344CB8AC3E}">
+        <p14:creationId xmlns:p14="http://schemas.microsoft.com/office/powerpoint/2010/main" val="1804572676"/>
+      </p:ext>
+    </p:extLst>
+  </p:cSld>
+  <p:clrMapOvr>
+    <a:masterClrMapping/>
+  </p:clrMapOvr>
+</p:sld>
+</file>
+
+<file path=ppt/slides/slide4.xml><?xml version="1.0" encoding="utf-8"?>
+<p:sld xmlns:a="http://schemas.openxmlformats.org/drawingml/2006/main" xmlns:r="http://schemas.openxmlformats.org/officeDocument/2006/relationships" xmlns:p="http://schemas.openxmlformats.org/presentationml/2006/main">
+  <p:cSld>
+    <p:spTree>
+      <p:nvGrpSpPr>
+        <p:cNvPr id="1" name=""/>
+        <p:cNvGrpSpPr/>
+        <p:nvPr/>
+      </p:nvGrpSpPr>
+      <p:grpSpPr>
+        <a:xfrm>
+          <a:off x="0" y="0"/>
+          <a:ext cx="0" cy="0"/>
+          <a:chOff x="0" y="0"/>
+          <a:chExt cx="0" cy="0"/>
+        </a:xfrm>
+      </p:grpSpPr>
+      <p:sp>
+        <p:nvSpPr>
+          <p:cNvPr id="2" name="제목 1"/>
+          <p:cNvSpPr>
+            <a:spLocks noGrp="1"/>
+          </p:cNvSpPr>
+          <p:nvPr>
+            <p:ph type="title"/>
+          </p:nvPr>
+        </p:nvSpPr>
+        <p:spPr/>
+        <p:txBody>
+          <a:bodyPr/>
+          <a:lstStyle/>
+          <a:p>
+            <a:r>
+              <a:rPr lang="ko-KR" altLang="en-US"/>
+              <a:t>캐릭터의 설정 </a:t>
+            </a:r>
+            <a:r>
+              <a:rPr lang="en-US" altLang="ko-KR"/>
+              <a:t>‘</a:t>
+            </a:r>
+            <a:r>
+              <a:rPr lang="ko-KR" altLang="en-US"/>
+              <a:t>구분 인자</a:t>
+            </a:r>
+            <a:r>
+              <a:rPr lang="en-US" altLang="ko-KR"/>
+              <a:t>’</a:t>
+            </a:r>
+            <a:r>
+              <a:rPr lang="ko-KR" altLang="en-US"/>
+              <a:t>들</a:t>
+            </a:r>
+          </a:p>
+        </p:txBody>
+      </p:sp>
+      <p:sp>
+        <p:nvSpPr>
+          <p:cNvPr id="3" name="내용 개체 틀 2"/>
+          <p:cNvSpPr>
+            <a:spLocks noGrp="1"/>
+          </p:cNvSpPr>
+          <p:nvPr>
+            <p:ph idx="1"/>
+          </p:nvPr>
+        </p:nvSpPr>
+        <p:spPr/>
+        <p:txBody>
+          <a:bodyPr>
+            <a:normAutofit fontScale="92500" lnSpcReduction="10000"/>
+          </a:bodyPr>
+          <a:lstStyle/>
+          <a:p>
+            <a:r>
+              <a:rPr lang="ko-KR" altLang="en-US"/>
+              <a:t>이름</a:t>
+            </a:r>
+            <a:endParaRPr lang="en-US" altLang="ko-KR"/>
+          </a:p>
+          <a:p>
+            <a:pPr lvl="1"/>
+            <a:r>
+              <a:rPr lang="ko-KR" altLang="en-US"/>
+              <a:t>나의 정체성을 나타내는 것</a:t>
+            </a:r>
+            <a:endParaRPr lang="en-US" altLang="ko-KR"/>
+          </a:p>
+          <a:p>
+            <a:r>
+              <a:rPr lang="ko-KR" altLang="en-US"/>
+              <a:t>배경 스토리</a:t>
+            </a:r>
+            <a:endParaRPr lang="en-US" altLang="ko-KR"/>
+          </a:p>
+          <a:p>
+            <a:r>
+              <a:rPr lang="ko-KR" altLang="en-US"/>
+              <a:t>메인 설정</a:t>
+            </a:r>
+            <a:endParaRPr lang="en-US" altLang="ko-KR"/>
+          </a:p>
+          <a:p>
+            <a:pPr lvl="1"/>
+            <a:r>
+              <a:rPr lang="ko-KR" altLang="en-US"/>
+              <a:t>가장 중심적인 설정</a:t>
+            </a:r>
+            <a:endParaRPr lang="en-US" altLang="ko-KR"/>
+          </a:p>
+          <a:p>
+            <a:r>
+              <a:rPr lang="ko-KR" altLang="en-US"/>
+              <a:t>프로필</a:t>
+            </a:r>
+            <a:endParaRPr lang="en-US" altLang="ko-KR"/>
+          </a:p>
+          <a:p>
+            <a:r>
+              <a:rPr lang="ko-KR" altLang="en-US"/>
+              <a:t>외형</a:t>
+            </a:r>
+            <a:endParaRPr lang="en-US" altLang="ko-KR"/>
+          </a:p>
+          <a:p>
+            <a:pPr marL="0" indent="0">
+              <a:buNone/>
+            </a:pPr>
+            <a:r>
+              <a:rPr lang="en-US" altLang="ko-KR"/>
+              <a:t>[</a:t>
+            </a:r>
+            <a:r>
+              <a:rPr lang="ko-KR" altLang="en-US"/>
+              <a:t>게임의 장르에 따라서 필요한 설정값</a:t>
+            </a:r>
+            <a:r>
+              <a:rPr lang="en-US" altLang="ko-KR"/>
+              <a:t>]</a:t>
+            </a:r>
+          </a:p>
+          <a:p>
+            <a:r>
+              <a:rPr lang="ko-KR" altLang="en-US"/>
+              <a:t>컨텐츠의 서식에 따른 설정</a:t>
+            </a:r>
+            <a:endParaRPr lang="en-US" altLang="ko-KR"/>
+          </a:p>
+          <a:p>
+            <a:r>
+              <a:rPr lang="ko-KR" altLang="en-US"/>
+              <a:t>소속</a:t>
+            </a:r>
+            <a:r>
+              <a:rPr lang="en-US" altLang="ko-KR"/>
+              <a:t>, </a:t>
+            </a:r>
+            <a:r>
+              <a:rPr lang="ko-KR" altLang="en-US"/>
+              <a:t>아이템</a:t>
+            </a:r>
+            <a:r>
+              <a:rPr lang="en-US" altLang="ko-KR"/>
+              <a:t>, </a:t>
+            </a:r>
+            <a:r>
+              <a:rPr lang="ko-KR" altLang="en-US"/>
+              <a:t>의성어</a:t>
+            </a:r>
+            <a:r>
+              <a:rPr lang="en-US" altLang="ko-KR"/>
+              <a:t>, </a:t>
+            </a:r>
+            <a:r>
+              <a:rPr lang="ko-KR" altLang="en-US"/>
+              <a:t>밸런스</a:t>
+            </a:r>
+            <a:endParaRPr lang="en-US" altLang="ko-KR"/>
+          </a:p>
+        </p:txBody>
+      </p:sp>
+    </p:spTree>
+    <p:extLst>
+      <p:ext uri="{BB962C8B-B14F-4D97-AF65-F5344CB8AC3E}">
+        <p14:creationId xmlns:p14="http://schemas.microsoft.com/office/powerpoint/2010/main" val="3290855989"/>
       </p:ext>
     </p:extLst>
   </p:cSld>
@@ -3851,253 +5567,6 @@
           <a:chExt cx="0" cy="0"/>
         </a:xfrm>
       </p:grpSpPr>
-      <p:pic>
-        <p:nvPicPr>
-          <p:cNvPr id="4" name="그림 3"/>
-          <p:cNvPicPr>
-            <a:picLocks noChangeAspect="1"/>
-          </p:cNvPicPr>
-          <p:nvPr/>
-        </p:nvPicPr>
-        <p:blipFill>
-          <a:blip r:embed="rId2"/>
-          <a:stretch>
-            <a:fillRect/>
-          </a:stretch>
-        </p:blipFill>
-        <p:spPr>
-          <a:xfrm>
-            <a:off x="266464" y="285751"/>
-            <a:ext cx="11659072" cy="6286498"/>
-          </a:xfrm>
-          <a:prstGeom prst="rect">
-            <a:avLst/>
-          </a:prstGeom>
-        </p:spPr>
-      </p:pic>
-    </p:spTree>
-    <p:extLst>
-      <p:ext uri="{BB962C8B-B14F-4D97-AF65-F5344CB8AC3E}">
-        <p14:creationId xmlns:p14="http://schemas.microsoft.com/office/powerpoint/2010/main" val="3570744376"/>
-      </p:ext>
-    </p:extLst>
-  </p:cSld>
-  <p:clrMapOvr>
-    <a:masterClrMapping/>
-  </p:clrMapOvr>
-</p:sld>
-</file>
-
-<file path=ppt/slides/slide6.xml><?xml version="1.0" encoding="utf-8"?>
-<p:sld xmlns:a="http://schemas.openxmlformats.org/drawingml/2006/main" xmlns:r="http://schemas.openxmlformats.org/officeDocument/2006/relationships" xmlns:p="http://schemas.openxmlformats.org/presentationml/2006/main">
-  <p:cSld>
-    <p:spTree>
-      <p:nvGrpSpPr>
-        <p:cNvPr id="1" name=""/>
-        <p:cNvGrpSpPr/>
-        <p:nvPr/>
-      </p:nvGrpSpPr>
-      <p:grpSpPr>
-        <a:xfrm>
-          <a:off x="0" y="0"/>
-          <a:ext cx="0" cy="0"/>
-          <a:chOff x="0" y="0"/>
-          <a:chExt cx="0" cy="0"/>
-        </a:xfrm>
-      </p:grpSpPr>
-      <p:sp>
-        <p:nvSpPr>
-          <p:cNvPr id="2" name="제목 1"/>
-          <p:cNvSpPr>
-            <a:spLocks noGrp="1"/>
-          </p:cNvSpPr>
-          <p:nvPr>
-            <p:ph type="title"/>
-          </p:nvPr>
-        </p:nvSpPr>
-        <p:spPr/>
-        <p:txBody>
-          <a:bodyPr/>
-          <a:lstStyle/>
-          <a:p>
-            <a:r>
-              <a:rPr lang="ko-KR" altLang="en-US" smtClean="0"/>
-              <a:t>캐릭터의 설정 </a:t>
-            </a:r>
-            <a:r>
-              <a:rPr lang="en-US" altLang="ko-KR" smtClean="0"/>
-              <a:t>‘</a:t>
-            </a:r>
-            <a:r>
-              <a:rPr lang="ko-KR" altLang="en-US" smtClean="0"/>
-              <a:t>구분 인자</a:t>
-            </a:r>
-            <a:r>
-              <a:rPr lang="en-US" altLang="ko-KR" smtClean="0"/>
-              <a:t>’</a:t>
-            </a:r>
-            <a:r>
-              <a:rPr lang="ko-KR" altLang="en-US" smtClean="0"/>
-              <a:t>들</a:t>
-            </a:r>
-            <a:endParaRPr lang="ko-KR" altLang="en-US"/>
-          </a:p>
-        </p:txBody>
-      </p:sp>
-      <p:sp>
-        <p:nvSpPr>
-          <p:cNvPr id="3" name="내용 개체 틀 2"/>
-          <p:cNvSpPr>
-            <a:spLocks noGrp="1"/>
-          </p:cNvSpPr>
-          <p:nvPr>
-            <p:ph idx="1"/>
-          </p:nvPr>
-        </p:nvSpPr>
-        <p:spPr/>
-        <p:txBody>
-          <a:bodyPr>
-            <a:normAutofit fontScale="92500" lnSpcReduction="10000"/>
-          </a:bodyPr>
-          <a:lstStyle/>
-          <a:p>
-            <a:r>
-              <a:rPr lang="ko-KR" altLang="en-US" smtClean="0"/>
-              <a:t>이름</a:t>
-            </a:r>
-            <a:endParaRPr lang="en-US" altLang="ko-KR" smtClean="0"/>
-          </a:p>
-          <a:p>
-            <a:pPr lvl="1"/>
-            <a:r>
-              <a:rPr lang="ko-KR" altLang="en-US" smtClean="0"/>
-              <a:t>나의 정체성을 나타내는 것</a:t>
-            </a:r>
-            <a:endParaRPr lang="en-US" altLang="ko-KR" smtClean="0"/>
-          </a:p>
-          <a:p>
-            <a:r>
-              <a:rPr lang="ko-KR" altLang="en-US" smtClean="0"/>
-              <a:t>배경 스토리</a:t>
-            </a:r>
-            <a:endParaRPr lang="en-US" altLang="ko-KR" smtClean="0"/>
-          </a:p>
-          <a:p>
-            <a:r>
-              <a:rPr lang="ko-KR" altLang="en-US" smtClean="0"/>
-              <a:t>메인 설정</a:t>
-            </a:r>
-            <a:endParaRPr lang="en-US" altLang="ko-KR" smtClean="0"/>
-          </a:p>
-          <a:p>
-            <a:pPr lvl="1"/>
-            <a:r>
-              <a:rPr lang="ko-KR" altLang="en-US" smtClean="0"/>
-              <a:t>가장 중심적인 설정</a:t>
-            </a:r>
-            <a:endParaRPr lang="en-US" altLang="ko-KR"/>
-          </a:p>
-          <a:p>
-            <a:r>
-              <a:rPr lang="ko-KR" altLang="en-US" smtClean="0"/>
-              <a:t>프로필</a:t>
-            </a:r>
-            <a:endParaRPr lang="en-US" altLang="ko-KR" smtClean="0"/>
-          </a:p>
-          <a:p>
-            <a:r>
-              <a:rPr lang="ko-KR" altLang="en-US" smtClean="0"/>
-              <a:t>외형</a:t>
-            </a:r>
-            <a:endParaRPr lang="en-US" altLang="ko-KR" smtClean="0"/>
-          </a:p>
-          <a:p>
-            <a:pPr marL="0" indent="0">
-              <a:buNone/>
-            </a:pPr>
-            <a:r>
-              <a:rPr lang="en-US" altLang="ko-KR"/>
-              <a:t>[</a:t>
-            </a:r>
-            <a:r>
-              <a:rPr lang="ko-KR" altLang="en-US" smtClean="0"/>
-              <a:t>게임의 장르에 따라서 필요한 설정값</a:t>
-            </a:r>
-            <a:r>
-              <a:rPr lang="en-US" altLang="ko-KR" smtClean="0"/>
-              <a:t>]</a:t>
-            </a:r>
-          </a:p>
-          <a:p>
-            <a:r>
-              <a:rPr lang="ko-KR" altLang="en-US" smtClean="0"/>
-              <a:t>컨텐츠의 서식에 따른 설정</a:t>
-            </a:r>
-            <a:endParaRPr lang="en-US" altLang="ko-KR" smtClean="0"/>
-          </a:p>
-          <a:p>
-            <a:r>
-              <a:rPr lang="ko-KR" altLang="en-US" smtClean="0"/>
-              <a:t>소속</a:t>
-            </a:r>
-            <a:r>
-              <a:rPr lang="en-US" altLang="ko-KR" smtClean="0"/>
-              <a:t>, </a:t>
-            </a:r>
-            <a:r>
-              <a:rPr lang="ko-KR" altLang="en-US" smtClean="0"/>
-              <a:t>아이템</a:t>
-            </a:r>
-            <a:r>
-              <a:rPr lang="en-US" altLang="ko-KR" smtClean="0"/>
-              <a:t>, </a:t>
-            </a:r>
-            <a:r>
-              <a:rPr lang="ko-KR" altLang="en-US" smtClean="0"/>
-              <a:t>의성어</a:t>
-            </a:r>
-            <a:r>
-              <a:rPr lang="en-US" altLang="ko-KR" smtClean="0"/>
-              <a:t>, </a:t>
-            </a:r>
-            <a:r>
-              <a:rPr lang="ko-KR" altLang="en-US" smtClean="0"/>
-              <a:t>밸런스</a:t>
-            </a:r>
-            <a:endParaRPr lang="en-US" altLang="ko-KR" smtClean="0"/>
-          </a:p>
-        </p:txBody>
-      </p:sp>
-    </p:spTree>
-    <p:extLst>
-      <p:ext uri="{BB962C8B-B14F-4D97-AF65-F5344CB8AC3E}">
-        <p14:creationId xmlns:p14="http://schemas.microsoft.com/office/powerpoint/2010/main" val="3290855989"/>
-      </p:ext>
-    </p:extLst>
-  </p:cSld>
-  <p:clrMapOvr>
-    <a:masterClrMapping/>
-  </p:clrMapOvr>
-</p:sld>
-</file>
-
-<file path=ppt/slides/slide7.xml><?xml version="1.0" encoding="utf-8"?>
-<p:sld xmlns:a="http://schemas.openxmlformats.org/drawingml/2006/main" xmlns:r="http://schemas.openxmlformats.org/officeDocument/2006/relationships" xmlns:p="http://schemas.openxmlformats.org/presentationml/2006/main">
-  <p:cSld>
-    <p:spTree>
-      <p:nvGrpSpPr>
-        <p:cNvPr id="1" name=""/>
-        <p:cNvGrpSpPr/>
-        <p:nvPr/>
-      </p:nvGrpSpPr>
-      <p:grpSpPr>
-        <a:xfrm>
-          <a:off x="0" y="0"/>
-          <a:ext cx="0" cy="0"/>
-          <a:chOff x="0" y="0"/>
-          <a:chExt cx="0" cy="0"/>
-        </a:xfrm>
-      </p:grpSpPr>
       <p:sp>
         <p:nvSpPr>
           <p:cNvPr id="2" name="제목 1"/>
@@ -4121,10 +5590,9 @@
           <a:lstStyle/>
           <a:p>
             <a:r>
-              <a:rPr lang="ko-KR" altLang="en-US" sz="3000" smtClean="0"/>
+              <a:rPr lang="ko-KR" altLang="en-US" sz="3000"/>
               <a:t>캐릭터 시트</a:t>
             </a:r>
-            <a:endParaRPr lang="ko-KR" altLang="en-US" sz="3000"/>
           </a:p>
         </p:txBody>
       </p:sp>
@@ -4137,14 +5605,14 @@
           <p:nvPr>
             <p:extLst>
               <p:ext uri="{D42A27DB-BD31-4B8C-83A1-F6EECF244321}">
-                <p14:modId xmlns:p14="http://schemas.microsoft.com/office/powerpoint/2010/main" val="1058057104"/>
+                <p14:modId xmlns:p14="http://schemas.microsoft.com/office/powerpoint/2010/main" val="887930547"/>
               </p:ext>
             </p:extLst>
           </p:nvPr>
         </p:nvGraphicFramePr>
         <p:xfrm>
-          <a:off x="2032000" y="719666"/>
-          <a:ext cx="8106319" cy="6172532"/>
+          <a:off x="406400" y="295336"/>
+          <a:ext cx="8106319" cy="6446852"/>
         </p:xfrm>
         <a:graphic>
           <a:graphicData uri="http://schemas.openxmlformats.org/drawingml/2006/table">
@@ -4197,10 +5665,9 @@
                     <a:p>
                       <a:pPr latinLnBrk="1"/>
                       <a:r>
-                        <a:rPr lang="ko-KR" altLang="en-US" smtClean="0"/>
+                        <a:rPr lang="ko-KR" altLang="en-US"/>
                         <a:t>이름</a:t>
                       </a:r>
-                      <a:endParaRPr lang="ko-KR" altLang="en-US"/>
                     </a:p>
                   </a:txBody>
                   <a:tcPr/>
@@ -4212,10 +5679,9 @@
                     <a:p>
                       <a:pPr latinLnBrk="1"/>
                       <a:r>
-                        <a:rPr lang="ko-KR" altLang="en-US" smtClean="0"/>
+                        <a:rPr lang="ko-KR" altLang="en-US"/>
                         <a:t>차한해</a:t>
                       </a:r>
-                      <a:endParaRPr lang="ko-KR" altLang="en-US"/>
                     </a:p>
                   </a:txBody>
                   <a:tcPr/>
@@ -4227,10 +5693,9 @@
                     <a:p>
                       <a:pPr latinLnBrk="1"/>
                       <a:r>
-                        <a:rPr lang="ko-KR" altLang="en-US" smtClean="0"/>
-                        <a:t>핵심 정의</a:t>
-                      </a:r>
-                      <a:endParaRPr lang="ko-KR" altLang="en-US"/>
+                        <a:rPr lang="ko-KR" altLang="en-US" dirty="0"/>
+                        <a:t>역할</a:t>
+                      </a:r>
                     </a:p>
                   </a:txBody>
                   <a:tcPr/>
@@ -4242,18 +5707,9 @@
                     <a:p>
                       <a:pPr latinLnBrk="1"/>
                       <a:r>
-                        <a:rPr lang="ko-KR" altLang="en-US" smtClean="0"/>
-                        <a:t>타인을 우선시하며</a:t>
-                      </a:r>
-                      <a:r>
-                        <a:rPr lang="en-US" altLang="ko-KR" smtClean="0"/>
-                        <a:t>, </a:t>
-                      </a:r>
-                      <a:r>
-                        <a:rPr lang="ko-KR" altLang="en-US" smtClean="0"/>
-                        <a:t>좋은 사람으로 보이고자 하는 성향</a:t>
-                      </a:r>
-                      <a:endParaRPr lang="ko-KR" altLang="en-US"/>
+                        <a:rPr lang="ko-KR" altLang="en-US" dirty="0"/>
+                        <a:t>선의의 강제 희생자</a:t>
+                      </a:r>
                     </a:p>
                   </a:txBody>
                   <a:tcPr/>
@@ -4283,10 +5739,9 @@
                     <a:p>
                       <a:pPr latinLnBrk="1"/>
                       <a:r>
-                        <a:rPr lang="ko-KR" altLang="en-US" smtClean="0"/>
-                        <a:t>복장</a:t>
-                      </a:r>
-                      <a:endParaRPr lang="ko-KR" altLang="en-US"/>
+                        <a:rPr lang="ko-KR" altLang="en-US" dirty="0"/>
+                        <a:t>성격</a:t>
+                      </a:r>
                     </a:p>
                   </a:txBody>
                   <a:tcPr/>
@@ -4298,10 +5753,49 @@
                     <a:p>
                       <a:pPr latinLnBrk="1"/>
                       <a:r>
-                        <a:rPr lang="ko-KR" altLang="en-US" smtClean="0"/>
-                        <a:t>활동이 편한 캐주얼 차림</a:t>
-                      </a:r>
-                      <a:endParaRPr lang="ko-KR" altLang="en-US"/>
+                        <a:rPr lang="ko-KR" altLang="en-US" dirty="0"/>
+                        <a:t>온화하고 순응적</a:t>
+                      </a:r>
+                      <a:r>
+                        <a:rPr lang="en-US" altLang="ko-KR" dirty="0"/>
+                        <a:t>. </a:t>
+                      </a:r>
+                      <a:r>
+                        <a:rPr lang="ko-KR" altLang="en-US" dirty="0"/>
+                        <a:t>스스로 착하다고 생각하지 않으나</a:t>
+                      </a:r>
+                      <a:r>
+                        <a:rPr lang="en-US" altLang="ko-KR" dirty="0"/>
+                        <a:t>, </a:t>
+                      </a:r>
+                      <a:r>
+                        <a:rPr lang="ko-KR" altLang="en-US" dirty="0"/>
+                        <a:t>주변의 </a:t>
+                      </a:r>
+                      <a:r>
+                        <a:rPr lang="en-US" altLang="ko-KR" dirty="0"/>
+                        <a:t>‘</a:t>
+                      </a:r>
+                      <a:r>
+                        <a:rPr lang="ko-KR" altLang="en-US" dirty="0"/>
+                        <a:t>가장 착한 사람</a:t>
+                      </a:r>
+                      <a:r>
+                        <a:rPr lang="en-US" altLang="ko-KR" dirty="0"/>
+                        <a:t>’ </a:t>
+                      </a:r>
+                      <a:r>
+                        <a:rPr lang="ko-KR" altLang="en-US" dirty="0"/>
+                        <a:t>평가에 만족</a:t>
+                      </a:r>
+                      <a:r>
+                        <a:rPr lang="en-US" altLang="ko-KR" dirty="0"/>
+                        <a:t>. </a:t>
+                      </a:r>
+                      <a:r>
+                        <a:rPr lang="ko-KR" altLang="en-US" dirty="0"/>
+                        <a:t>점차 희생 강요에 피로를 느낌</a:t>
+                      </a:r>
                     </a:p>
                   </a:txBody>
                   <a:tcPr/>
@@ -4313,10 +5807,9 @@
                     <a:p>
                       <a:pPr latinLnBrk="1"/>
                       <a:r>
-                        <a:rPr lang="ko-KR" altLang="en-US" smtClean="0"/>
-                        <a:t>특징</a:t>
-                      </a:r>
-                      <a:endParaRPr lang="ko-KR" altLang="en-US"/>
+                        <a:rPr lang="ko-KR" altLang="en-US" dirty="0"/>
+                        <a:t>선의 지수</a:t>
+                      </a:r>
                     </a:p>
                   </a:txBody>
                   <a:tcPr/>
@@ -4328,10 +5821,9 @@
                     <a:p>
                       <a:pPr latinLnBrk="1"/>
                       <a:r>
-                        <a:rPr lang="ko-KR" altLang="en-US" smtClean="0"/>
-                        <a:t>소지품을 넉넉히 챙겨다니는 습관</a:t>
-                      </a:r>
-                      <a:endParaRPr lang="ko-KR" altLang="en-US"/>
+                        <a:rPr lang="ko-KR" altLang="en-US" dirty="0"/>
+                        <a:t>무한대</a:t>
+                      </a:r>
                     </a:p>
                   </a:txBody>
                   <a:tcPr/>
@@ -4361,10 +5853,9 @@
                     <a:p>
                       <a:pPr latinLnBrk="1"/>
                       <a:r>
-                        <a:rPr lang="ko-KR" altLang="en-US" smtClean="0"/>
+                        <a:rPr lang="ko-KR" altLang="en-US"/>
                         <a:t>약점</a:t>
                       </a:r>
-                      <a:endParaRPr lang="ko-KR" altLang="en-US"/>
                     </a:p>
                   </a:txBody>
                   <a:tcPr/>
@@ -4376,10 +5867,9 @@
                     <a:p>
                       <a:pPr latinLnBrk="1"/>
                       <a:r>
-                        <a:rPr lang="ko-KR" altLang="en-US" smtClean="0"/>
+                        <a:rPr lang="ko-KR" altLang="en-US"/>
                         <a:t>타인의 평가에 쉽게 흔들림</a:t>
                       </a:r>
-                      <a:endParaRPr lang="ko-KR" altLang="en-US"/>
                     </a:p>
                   </a:txBody>
                   <a:tcPr/>
@@ -4431,10 +5921,9 @@
                     <a:p>
                       <a:pPr latinLnBrk="1"/>
                       <a:r>
-                        <a:rPr lang="ko-KR" altLang="en-US" smtClean="0"/>
+                        <a:rPr lang="ko-KR" altLang="en-US"/>
                         <a:t>배경 이야기</a:t>
                       </a:r>
-                      <a:endParaRPr lang="ko-KR" altLang="en-US"/>
                     </a:p>
                   </a:txBody>
                   <a:tcPr/>
@@ -4446,49 +5935,21 @@
                     <a:p>
                       <a:pPr latinLnBrk="1"/>
                       <a:r>
-                        <a:rPr lang="ko-KR" altLang="en-US" smtClean="0"/>
-                        <a:t>차한해는 가족을 돌보는 역할 속에서 성장하며</a:t>
-                      </a:r>
-                      <a:r>
-                        <a:rPr lang="en-US" altLang="ko-KR" smtClean="0"/>
-                        <a:t>, </a:t>
-                      </a:r>
-                      <a:r>
-                        <a:rPr lang="ko-KR" altLang="en-US" smtClean="0"/>
-                        <a:t>타인의 기대에 부응하는 것이 관계를 유지하는 방식이라 믿게 되었다</a:t>
-                      </a:r>
-                      <a:r>
-                        <a:rPr lang="en-US" altLang="ko-KR" smtClean="0"/>
-                        <a:t>.</a:t>
-                      </a:r>
-                      <a:br>
-                        <a:rPr lang="en-US" altLang="ko-KR" smtClean="0"/>
-                      </a:br>
-                      <a:r>
-                        <a:rPr lang="ko-KR" altLang="en-US" smtClean="0"/>
-                        <a:t>그 결과</a:t>
-                      </a:r>
-                      <a:r>
-                        <a:rPr lang="en-US" altLang="ko-KR" smtClean="0"/>
-                        <a:t>, </a:t>
-                      </a:r>
-                      <a:r>
-                        <a:rPr lang="ko-KR" altLang="en-US" smtClean="0"/>
-                        <a:t>타인의 시선을 의식하며 ‘좋은 사람’으로 보이고자 하는 욕구가 형성되었고</a:t>
-                      </a:r>
-                      <a:r>
-                        <a:rPr lang="en-US" altLang="ko-KR" smtClean="0"/>
-                        <a:t>, </a:t>
-                      </a:r>
-                      <a:r>
-                        <a:rPr lang="ko-KR" altLang="en-US" smtClean="0"/>
-                        <a:t>부탁을 거절하기보다 받아들이는 선택에 익숙해진 인물이다</a:t>
-                      </a:r>
-                      <a:r>
-                        <a:rPr lang="en-US" altLang="ko-KR" smtClean="0"/>
-                        <a:t>.</a:t>
-                      </a:r>
-                      <a:endParaRPr lang="ko-KR" altLang="en-US"/>
+                        <a:rPr lang="ko-KR" altLang="en-US" dirty="0"/>
+                        <a:t>입양 장녀로 어린 시절부터 부모와 친동생에게 지속적 희생을 </a:t>
+                      </a:r>
+                      <a:r>
+                        <a:rPr lang="ko-KR" altLang="en-US" dirty="0" err="1"/>
+                        <a:t>강요받음</a:t>
+                      </a:r>
+                      <a:r>
+                        <a:rPr lang="en-US" altLang="ko-KR" dirty="0"/>
+                        <a:t>. </a:t>
+                      </a:r>
+                      <a:r>
+                        <a:rPr lang="ko-KR" altLang="en-US" dirty="0"/>
+                        <a:t>착한 아이 증후군으로 선행에 강박을 지님</a:t>
+                      </a:r>
                     </a:p>
                   </a:txBody>
                   <a:tcPr/>
@@ -4540,7 +6001,7 @@
                     <a:p>
                       <a:pPr latinLnBrk="1"/>
                       <a:r>
-                        <a:rPr lang="en-US" altLang="ko-KR" smtClean="0"/>
+                        <a:rPr lang="en-US" altLang="ko-KR"/>
                         <a:t>2D</a:t>
                       </a:r>
                       <a:endParaRPr lang="ko-KR" altLang="en-US"/>
@@ -4566,10 +6027,9 @@
                     <a:p>
                       <a:pPr latinLnBrk="1"/>
                       <a:r>
-                        <a:rPr lang="ko-KR" altLang="en-US" smtClean="0"/>
+                        <a:rPr lang="ko-KR" altLang="en-US" dirty="0"/>
                         <a:t>도트</a:t>
                       </a:r>
-                      <a:endParaRPr lang="ko-KR" altLang="en-US"/>
                     </a:p>
                   </a:txBody>
                   <a:tcPr/>
@@ -4591,7 +6051,7 @@
                     <a:lstStyle/>
                     <a:p>
                       <a:pPr latinLnBrk="1"/>
-                      <a:endParaRPr lang="ko-KR" altLang="en-US"/>
+                      <a:endParaRPr lang="ko-KR" altLang="en-US" dirty="0"/>
                     </a:p>
                   </a:txBody>
                   <a:tcPr/>
@@ -4649,7 +6109,7 @@
         </p:blipFill>
         <p:spPr>
           <a:xfrm>
-            <a:off x="4630108" y="4772301"/>
+            <a:off x="3321261" y="4901235"/>
             <a:ext cx="627692" cy="1623419"/>
           </a:xfrm>
           <a:prstGeom prst="rect">
@@ -4696,7 +6156,7 @@
         </p:blipFill>
         <p:spPr>
           <a:xfrm>
-            <a:off x="8809679" y="5429094"/>
+            <a:off x="7297632" y="5419600"/>
             <a:ext cx="552527" cy="1105054"/>
           </a:xfrm>
           <a:prstGeom prst="rect">
@@ -4708,6 +6168,345 @@
     <p:extLst>
       <p:ext uri="{BB962C8B-B14F-4D97-AF65-F5344CB8AC3E}">
         <p14:creationId xmlns:p14="http://schemas.microsoft.com/office/powerpoint/2010/main" val="1102067116"/>
+      </p:ext>
+    </p:extLst>
+  </p:cSld>
+  <p:clrMapOvr>
+    <a:masterClrMapping/>
+  </p:clrMapOvr>
+</p:sld>
+</file>
+
+<file path=ppt/slides/slide6.xml><?xml version="1.0" encoding="utf-8"?>
+<p:sld xmlns:a="http://schemas.openxmlformats.org/drawingml/2006/main" xmlns:r="http://schemas.openxmlformats.org/officeDocument/2006/relationships" xmlns:p="http://schemas.openxmlformats.org/presentationml/2006/main">
+  <p:cSld>
+    <p:spTree>
+      <p:nvGrpSpPr>
+        <p:cNvPr id="1" name=""/>
+        <p:cNvGrpSpPr/>
+        <p:nvPr/>
+      </p:nvGrpSpPr>
+      <p:grpSpPr>
+        <a:xfrm>
+          <a:off x="0" y="0"/>
+          <a:ext cx="0" cy="0"/>
+          <a:chOff x="0" y="0"/>
+          <a:chExt cx="0" cy="0"/>
+        </a:xfrm>
+      </p:grpSpPr>
+      <p:pic>
+        <p:nvPicPr>
+          <p:cNvPr id="5" name="그림 4">
+            <a:extLst>
+              <a:ext uri="{FF2B5EF4-FFF2-40B4-BE49-F238E27FC236}">
+                <a16:creationId xmlns:a16="http://schemas.microsoft.com/office/drawing/2014/main" id="{ECCEBF64-9B3F-B976-F13F-1254C6BD7FEA}"/>
+              </a:ext>
+            </a:extLst>
+          </p:cNvPr>
+          <p:cNvPicPr>
+            <a:picLocks noChangeAspect="1"/>
+          </p:cNvPicPr>
+          <p:nvPr/>
+        </p:nvPicPr>
+        <p:blipFill>
+          <a:blip r:embed="rId2"/>
+          <a:stretch>
+            <a:fillRect/>
+          </a:stretch>
+        </p:blipFill>
+        <p:spPr>
+          <a:xfrm>
+            <a:off x="2107822" y="256874"/>
+            <a:ext cx="7976356" cy="6344251"/>
+          </a:xfrm>
+          <a:prstGeom prst="rect">
+            <a:avLst/>
+          </a:prstGeom>
+        </p:spPr>
+      </p:pic>
+    </p:spTree>
+    <p:extLst>
+      <p:ext uri="{BB962C8B-B14F-4D97-AF65-F5344CB8AC3E}">
+        <p14:creationId xmlns:p14="http://schemas.microsoft.com/office/powerpoint/2010/main" val="1384166840"/>
+      </p:ext>
+    </p:extLst>
+  </p:cSld>
+  <p:clrMapOvr>
+    <a:masterClrMapping/>
+  </p:clrMapOvr>
+</p:sld>
+</file>
+
+<file path=ppt/slides/slide7.xml><?xml version="1.0" encoding="utf-8"?>
+<p:sld xmlns:a="http://schemas.openxmlformats.org/drawingml/2006/main" xmlns:r="http://schemas.openxmlformats.org/officeDocument/2006/relationships" xmlns:p="http://schemas.openxmlformats.org/presentationml/2006/main">
+  <p:cSld>
+    <p:spTree>
+      <p:nvGrpSpPr>
+        <p:cNvPr id="1" name=""/>
+        <p:cNvGrpSpPr/>
+        <p:nvPr/>
+      </p:nvGrpSpPr>
+      <p:grpSpPr>
+        <a:xfrm>
+          <a:off x="0" y="0"/>
+          <a:ext cx="0" cy="0"/>
+          <a:chOff x="0" y="0"/>
+          <a:chExt cx="0" cy="0"/>
+        </a:xfrm>
+      </p:grpSpPr>
+      <p:pic>
+        <p:nvPicPr>
+          <p:cNvPr id="5" name="그림 4">
+            <a:extLst>
+              <a:ext uri="{FF2B5EF4-FFF2-40B4-BE49-F238E27FC236}">
+                <a16:creationId xmlns:a16="http://schemas.microsoft.com/office/drawing/2014/main" id="{56CBF099-E19A-0115-F5C2-F6949C71F6CE}"/>
+              </a:ext>
+            </a:extLst>
+          </p:cNvPr>
+          <p:cNvPicPr>
+            <a:picLocks noChangeAspect="1"/>
+          </p:cNvPicPr>
+          <p:nvPr/>
+        </p:nvPicPr>
+        <p:blipFill>
+          <a:blip r:embed="rId2"/>
+          <a:stretch>
+            <a:fillRect/>
+          </a:stretch>
+        </p:blipFill>
+        <p:spPr>
+          <a:xfrm>
+            <a:off x="2920345" y="0"/>
+            <a:ext cx="6351309" cy="6858000"/>
+          </a:xfrm>
+          <a:prstGeom prst="rect">
+            <a:avLst/>
+          </a:prstGeom>
+        </p:spPr>
+      </p:pic>
+    </p:spTree>
+    <p:extLst>
+      <p:ext uri="{BB962C8B-B14F-4D97-AF65-F5344CB8AC3E}">
+        <p14:creationId xmlns:p14="http://schemas.microsoft.com/office/powerpoint/2010/main" val="2504027400"/>
+      </p:ext>
+    </p:extLst>
+  </p:cSld>
+  <p:clrMapOvr>
+    <a:masterClrMapping/>
+  </p:clrMapOvr>
+</p:sld>
+</file>
+
+<file path=ppt/slides/slide8.xml><?xml version="1.0" encoding="utf-8"?>
+<p:sld xmlns:a="http://schemas.openxmlformats.org/drawingml/2006/main" xmlns:r="http://schemas.openxmlformats.org/officeDocument/2006/relationships" xmlns:p="http://schemas.openxmlformats.org/presentationml/2006/main">
+  <p:cSld>
+    <p:spTree>
+      <p:nvGrpSpPr>
+        <p:cNvPr id="1" name=""/>
+        <p:cNvGrpSpPr/>
+        <p:nvPr/>
+      </p:nvGrpSpPr>
+      <p:grpSpPr>
+        <a:xfrm>
+          <a:off x="0" y="0"/>
+          <a:ext cx="0" cy="0"/>
+          <a:chOff x="0" y="0"/>
+          <a:chExt cx="0" cy="0"/>
+        </a:xfrm>
+      </p:grpSpPr>
+      <p:sp>
+        <p:nvSpPr>
+          <p:cNvPr id="2" name="제목 1">
+            <a:extLst>
+              <a:ext uri="{FF2B5EF4-FFF2-40B4-BE49-F238E27FC236}">
+                <a16:creationId xmlns:a16="http://schemas.microsoft.com/office/drawing/2014/main" id="{3ED56ABE-DFAE-8F12-5D19-8687A82FFDFD}"/>
+              </a:ext>
+            </a:extLst>
+          </p:cNvPr>
+          <p:cNvSpPr>
+            <a:spLocks noGrp="1"/>
+          </p:cNvSpPr>
+          <p:nvPr>
+            <p:ph type="title"/>
+          </p:nvPr>
+        </p:nvSpPr>
+        <p:spPr/>
+        <p:txBody>
+          <a:bodyPr/>
+          <a:lstStyle/>
+          <a:p>
+            <a:endParaRPr lang="ko-KR" altLang="en-US"/>
+          </a:p>
+        </p:txBody>
+      </p:sp>
+      <p:sp>
+        <p:nvSpPr>
+          <p:cNvPr id="3" name="내용 개체 틀 2">
+            <a:extLst>
+              <a:ext uri="{FF2B5EF4-FFF2-40B4-BE49-F238E27FC236}">
+                <a16:creationId xmlns:a16="http://schemas.microsoft.com/office/drawing/2014/main" id="{DD2DA624-7E84-0FD8-C71D-D8CB1FC5A657}"/>
+              </a:ext>
+            </a:extLst>
+          </p:cNvPr>
+          <p:cNvSpPr>
+            <a:spLocks noGrp="1"/>
+          </p:cNvSpPr>
+          <p:nvPr>
+            <p:ph idx="1"/>
+          </p:nvPr>
+        </p:nvSpPr>
+        <p:spPr/>
+        <p:txBody>
+          <a:bodyPr/>
+          <a:lstStyle/>
+          <a:p>
+            <a:endParaRPr lang="ko-KR" altLang="en-US"/>
+          </a:p>
+        </p:txBody>
+      </p:sp>
+      <p:pic>
+        <p:nvPicPr>
+          <p:cNvPr id="5" name="그림 4">
+            <a:extLst>
+              <a:ext uri="{FF2B5EF4-FFF2-40B4-BE49-F238E27FC236}">
+                <a16:creationId xmlns:a16="http://schemas.microsoft.com/office/drawing/2014/main" id="{B04A8D6E-AEFB-BE90-2C53-0BA7AF7D9663}"/>
+              </a:ext>
+            </a:extLst>
+          </p:cNvPr>
+          <p:cNvPicPr>
+            <a:picLocks noChangeAspect="1"/>
+          </p:cNvPicPr>
+          <p:nvPr/>
+        </p:nvPicPr>
+        <p:blipFill rotWithShape="1">
+          <a:blip r:embed="rId2"/>
+          <a:srcRect r="51670"/>
+          <a:stretch/>
+        </p:blipFill>
+        <p:spPr>
+          <a:xfrm>
+            <a:off x="1061867" y="0"/>
+            <a:ext cx="4865967" cy="6858000"/>
+          </a:xfrm>
+          <a:prstGeom prst="rect">
+            <a:avLst/>
+          </a:prstGeom>
+        </p:spPr>
+      </p:pic>
+    </p:spTree>
+    <p:extLst>
+      <p:ext uri="{BB962C8B-B14F-4D97-AF65-F5344CB8AC3E}">
+        <p14:creationId xmlns:p14="http://schemas.microsoft.com/office/powerpoint/2010/main" val="473193607"/>
+      </p:ext>
+    </p:extLst>
+  </p:cSld>
+  <p:clrMapOvr>
+    <a:masterClrMapping/>
+  </p:clrMapOvr>
+</p:sld>
+</file>
+
+<file path=ppt/slides/slide9.xml><?xml version="1.0" encoding="utf-8"?>
+<p:sld xmlns:a="http://schemas.openxmlformats.org/drawingml/2006/main" xmlns:r="http://schemas.openxmlformats.org/officeDocument/2006/relationships" xmlns:p="http://schemas.openxmlformats.org/presentationml/2006/main">
+  <p:cSld>
+    <p:spTree>
+      <p:nvGrpSpPr>
+        <p:cNvPr id="1" name=""/>
+        <p:cNvGrpSpPr/>
+        <p:nvPr/>
+      </p:nvGrpSpPr>
+      <p:grpSpPr>
+        <a:xfrm>
+          <a:off x="0" y="0"/>
+          <a:ext cx="0" cy="0"/>
+          <a:chOff x="0" y="0"/>
+          <a:chExt cx="0" cy="0"/>
+        </a:xfrm>
+      </p:grpSpPr>
+      <p:sp>
+        <p:nvSpPr>
+          <p:cNvPr id="2" name="제목 1">
+            <a:extLst>
+              <a:ext uri="{FF2B5EF4-FFF2-40B4-BE49-F238E27FC236}">
+                <a16:creationId xmlns:a16="http://schemas.microsoft.com/office/drawing/2014/main" id="{A6A82F35-3529-585C-EAF4-BCF35E3B427A}"/>
+              </a:ext>
+            </a:extLst>
+          </p:cNvPr>
+          <p:cNvSpPr>
+            <a:spLocks noGrp="1"/>
+          </p:cNvSpPr>
+          <p:nvPr>
+            <p:ph type="title"/>
+          </p:nvPr>
+        </p:nvSpPr>
+        <p:spPr/>
+        <p:txBody>
+          <a:bodyPr/>
+          <a:lstStyle/>
+          <a:p>
+            <a:endParaRPr lang="ko-KR" altLang="en-US"/>
+          </a:p>
+        </p:txBody>
+      </p:sp>
+      <p:sp>
+        <p:nvSpPr>
+          <p:cNvPr id="3" name="내용 개체 틀 2">
+            <a:extLst>
+              <a:ext uri="{FF2B5EF4-FFF2-40B4-BE49-F238E27FC236}">
+                <a16:creationId xmlns:a16="http://schemas.microsoft.com/office/drawing/2014/main" id="{CD4D5D3C-E1E5-E4E0-002C-DFA1ABBCCCA2}"/>
+              </a:ext>
+            </a:extLst>
+          </p:cNvPr>
+          <p:cNvSpPr>
+            <a:spLocks noGrp="1"/>
+          </p:cNvSpPr>
+          <p:nvPr>
+            <p:ph idx="1"/>
+          </p:nvPr>
+        </p:nvSpPr>
+        <p:spPr/>
+        <p:txBody>
+          <a:bodyPr/>
+          <a:lstStyle/>
+          <a:p>
+            <a:endParaRPr lang="ko-KR" altLang="en-US"/>
+          </a:p>
+        </p:txBody>
+      </p:sp>
+      <p:pic>
+        <p:nvPicPr>
+          <p:cNvPr id="5" name="그림 4">
+            <a:extLst>
+              <a:ext uri="{FF2B5EF4-FFF2-40B4-BE49-F238E27FC236}">
+                <a16:creationId xmlns:a16="http://schemas.microsoft.com/office/drawing/2014/main" id="{2C0824AB-8A4D-1985-76E5-549873A22BFA}"/>
+              </a:ext>
+            </a:extLst>
+          </p:cNvPr>
+          <p:cNvPicPr>
+            <a:picLocks noChangeAspect="1"/>
+          </p:cNvPicPr>
+          <p:nvPr/>
+        </p:nvPicPr>
+        <p:blipFill>
+          <a:blip r:embed="rId2"/>
+          <a:stretch>
+            <a:fillRect/>
+          </a:stretch>
+        </p:blipFill>
+        <p:spPr>
+          <a:xfrm>
+            <a:off x="110789" y="0"/>
+            <a:ext cx="11970421" cy="6858000"/>
+          </a:xfrm>
+          <a:prstGeom prst="rect">
+            <a:avLst/>
+          </a:prstGeom>
+        </p:spPr>
+      </p:pic>
+    </p:spTree>
+    <p:extLst>
+      <p:ext uri="{BB962C8B-B14F-4D97-AF65-F5344CB8AC3E}">
+        <p14:creationId xmlns:p14="http://schemas.microsoft.com/office/powerpoint/2010/main" val="1102019427"/>
       </p:ext>
     </p:extLst>
   </p:cSld>

</xml_diff>